<commit_message>
update PowerPoint: added Graphics and animation for Biary Files
</commit_message>
<xml_diff>
--- a/pp/Presentation.pptx
+++ b/pp/Presentation.pptx
@@ -10,7 +10,9 @@
     <p:sldId id="258" r:id="rId4"/>
     <p:sldId id="261" r:id="rId5"/>
     <p:sldId id="259" r:id="rId6"/>
-    <p:sldId id="260" r:id="rId7"/>
+    <p:sldId id="263" r:id="rId7"/>
+    <p:sldId id="262" r:id="rId8"/>
+    <p:sldId id="260" r:id="rId9"/>
   </p:sldIdLst>
   <p:sldSz cx="12192000" cy="6858000"/>
   <p:notesSz cx="6858000" cy="9144000"/>
@@ -3428,7 +3430,15 @@
           <a:lstStyle/>
           <a:p>
             <a:r>
-              <a:rPr lang="de-DE" sz="5100"/>
+              <a:rPr lang="de-DE" sz="5100" b="1" u="sng" dirty="0">
+                <a:effectLst>
+                  <a:outerShdw blurRad="38100" dist="38100" dir="2700000" algn="tl">
+                    <a:srgbClr val="000000">
+                      <a:alpha val="43137"/>
+                    </a:srgbClr>
+                  </a:outerShdw>
+                </a:effectLst>
+              </a:rPr>
               <a:t>Passwortmanager</a:t>
             </a:r>
           </a:p>
@@ -4561,7 +4571,15 @@
           <a:lstStyle/>
           <a:p>
             <a:r>
-              <a:rPr lang="de-DE" dirty="0"/>
+              <a:rPr lang="de-DE" b="1" dirty="0">
+                <a:effectLst>
+                  <a:outerShdw blurRad="38100" dist="38100" dir="2700000" algn="tl">
+                    <a:srgbClr val="000000">
+                      <a:alpha val="43137"/>
+                    </a:srgbClr>
+                  </a:outerShdw>
+                </a:effectLst>
+              </a:rPr>
               <a:t>Verwendete Technologien</a:t>
             </a:r>
           </a:p>
@@ -4643,18 +4661,23 @@
           <a:p>
             <a:r>
               <a:rPr lang="de-DE" sz="2000" dirty="0"/>
-              <a:t>Docker </a:t>
-            </a:r>
-            <a:r>
-              <a:rPr lang="de-DE" sz="2000" dirty="0" err="1"/>
-              <a:t>Compose</a:t>
-            </a:r>
-            <a:endParaRPr lang="de-DE" sz="2000" dirty="0"/>
+              <a:t>Docker Compose</a:t>
+            </a:r>
           </a:p>
           <a:p>
             <a:r>
               <a:rPr lang="de-DE" sz="2000" dirty="0"/>
-              <a:t>phpMyAdmin (optional)</a:t>
+              <a:t>phpMyAdmin (optional </a:t>
+            </a:r>
+            <a:r>
+              <a:rPr lang="de-DE" sz="2000" dirty="0">
+                <a:sym typeface="Wingdings" panose="05000000000000000000" pitchFamily="2" charset="2"/>
+              </a:rPr>
+              <a:t> verwendet zum Debuggen</a:t>
+            </a:r>
+            <a:r>
+              <a:rPr lang="de-DE" sz="2000" dirty="0"/>
+              <a:t>)</a:t>
             </a:r>
           </a:p>
         </p:txBody>
@@ -4711,7 +4734,15 @@
           <a:lstStyle/>
           <a:p>
             <a:r>
-              <a:rPr lang="de-DE" dirty="0"/>
+              <a:rPr lang="de-DE" b="1" dirty="0">
+                <a:effectLst>
+                  <a:outerShdw blurRad="38100" dist="38100" dir="2700000" algn="tl">
+                    <a:srgbClr val="000000">
+                      <a:alpha val="43137"/>
+                    </a:srgbClr>
+                  </a:outerShdw>
+                </a:effectLst>
+              </a:rPr>
               <a:t>Technischer Hintergrund</a:t>
             </a:r>
           </a:p>
@@ -5075,7 +5106,15 @@
           <a:lstStyle/>
           <a:p>
             <a:r>
-              <a:rPr lang="de-DE" dirty="0"/>
+              <a:rPr lang="de-DE" b="1" dirty="0">
+                <a:effectLst>
+                  <a:outerShdw blurRad="38100" dist="38100" dir="2700000" algn="tl">
+                    <a:srgbClr val="000000">
+                      <a:alpha val="43137"/>
+                    </a:srgbClr>
+                  </a:outerShdw>
+                </a:effectLst>
+              </a:rPr>
               <a:t>Technischer Hintergrund</a:t>
             </a:r>
           </a:p>
@@ -6325,9 +6364,38 @@
           <a:lstStyle/>
           <a:p>
             <a:r>
-              <a:rPr lang="de-DE" dirty="0"/>
-              <a:t>Umsetzung</a:t>
-            </a:r>
+              <a:rPr lang="de-DE" b="1" dirty="0">
+                <a:effectLst>
+                  <a:outerShdw blurRad="38100" dist="38100" dir="2700000" algn="tl">
+                    <a:srgbClr val="000000">
+                      <a:alpha val="43137"/>
+                    </a:srgbClr>
+                  </a:outerShdw>
+                </a:effectLst>
+              </a:rPr>
+              <a:t>Umsetzung </a:t>
+            </a:r>
+            <a:r>
+              <a:rPr lang="de-DE" dirty="0">
+                <a:effectLst>
+                  <a:outerShdw blurRad="38100" dist="38100" dir="2700000" algn="tl">
+                    <a:srgbClr val="000000">
+                      <a:alpha val="43137"/>
+                    </a:srgbClr>
+                  </a:outerShdw>
+                </a:effectLst>
+              </a:rPr>
+              <a:t>- </a:t>
+            </a:r>
+            <a:endParaRPr lang="de-DE" b="1" dirty="0">
+              <a:effectLst>
+                <a:outerShdw blurRad="38100" dist="38100" dir="2700000" algn="tl">
+                  <a:srgbClr val="000000">
+                    <a:alpha val="43137"/>
+                  </a:srgbClr>
+                </a:outerShdw>
+              </a:effectLst>
+            </a:endParaRPr>
           </a:p>
         </p:txBody>
       </p:sp>
@@ -6352,7 +6420,7 @@
           <a:bodyPr/>
           <a:lstStyle/>
           <a:p>
-            <a:endParaRPr lang="de-DE"/>
+            <a:endParaRPr lang="de-DE" dirty="0"/>
           </a:p>
         </p:txBody>
       </p:sp>
@@ -6374,6 +6442,672 @@
   <p:cSld>
     <p:spTree>
       <p:nvGrpSpPr>
+        <p:cNvPr id="1" name="">
+          <a:extLst>
+            <a:ext uri="{FF2B5EF4-FFF2-40B4-BE49-F238E27FC236}">
+              <a16:creationId xmlns:a16="http://schemas.microsoft.com/office/drawing/2014/main" id="{D47F335A-FDF6-4F22-13CA-08ED29DA569C}"/>
+            </a:ext>
+          </a:extLst>
+        </p:cNvPr>
+        <p:cNvGrpSpPr/>
+        <p:nvPr/>
+      </p:nvGrpSpPr>
+      <p:grpSpPr>
+        <a:xfrm>
+          <a:off x="0" y="0"/>
+          <a:ext cx="0" cy="0"/>
+          <a:chOff x="0" y="0"/>
+          <a:chExt cx="0" cy="0"/>
+        </a:xfrm>
+      </p:grpSpPr>
+      <p:sp>
+        <p:nvSpPr>
+          <p:cNvPr id="2" name="Titel 1">
+            <a:extLst>
+              <a:ext uri="{FF2B5EF4-FFF2-40B4-BE49-F238E27FC236}">
+                <a16:creationId xmlns:a16="http://schemas.microsoft.com/office/drawing/2014/main" id="{6C3531C2-260F-3E4A-71D3-613883B29F3F}"/>
+              </a:ext>
+            </a:extLst>
+          </p:cNvPr>
+          <p:cNvSpPr>
+            <a:spLocks noGrp="1"/>
+          </p:cNvSpPr>
+          <p:nvPr>
+            <p:ph type="title"/>
+          </p:nvPr>
+        </p:nvSpPr>
+        <p:spPr/>
+        <p:txBody>
+          <a:bodyPr/>
+          <a:lstStyle/>
+          <a:p>
+            <a:r>
+              <a:rPr lang="de-DE" b="1" dirty="0">
+                <a:effectLst>
+                  <a:outerShdw blurRad="38100" dist="38100" dir="2700000" algn="tl">
+                    <a:srgbClr val="000000">
+                      <a:alpha val="43137"/>
+                    </a:srgbClr>
+                  </a:outerShdw>
+                </a:effectLst>
+              </a:rPr>
+              <a:t>Umsetzung</a:t>
+            </a:r>
+            <a:r>
+              <a:rPr lang="de-DE" dirty="0">
+                <a:effectLst>
+                  <a:outerShdw blurRad="38100" dist="38100" dir="2700000" algn="tl">
+                    <a:srgbClr val="000000">
+                      <a:alpha val="43137"/>
+                    </a:srgbClr>
+                  </a:outerShdw>
+                </a:effectLst>
+              </a:rPr>
+              <a:t> - Verschlüsselung</a:t>
+            </a:r>
+          </a:p>
+        </p:txBody>
+      </p:sp>
+      <p:sp>
+        <p:nvSpPr>
+          <p:cNvPr id="3" name="Inhaltsplatzhalter 2">
+            <a:extLst>
+              <a:ext uri="{FF2B5EF4-FFF2-40B4-BE49-F238E27FC236}">
+                <a16:creationId xmlns:a16="http://schemas.microsoft.com/office/drawing/2014/main" id="{68F71C22-1CEE-7C61-96C3-081EEC5F2B92}"/>
+              </a:ext>
+            </a:extLst>
+          </p:cNvPr>
+          <p:cNvSpPr>
+            <a:spLocks noGrp="1"/>
+          </p:cNvSpPr>
+          <p:nvPr>
+            <p:ph idx="1"/>
+          </p:nvPr>
+        </p:nvSpPr>
+        <p:spPr/>
+        <p:txBody>
+          <a:bodyPr>
+            <a:normAutofit/>
+          </a:bodyPr>
+          <a:lstStyle/>
+          <a:p>
+            <a:r>
+              <a:rPr lang="de-DE" sz="1800" b="1" dirty="0"/>
+              <a:t>Allgemein:</a:t>
+            </a:r>
+            <a:endParaRPr lang="de-DE" sz="2000" b="1" dirty="0"/>
+          </a:p>
+        </p:txBody>
+      </p:sp>
+    </p:spTree>
+    <p:extLst>
+      <p:ext uri="{BB962C8B-B14F-4D97-AF65-F5344CB8AC3E}">
+        <p14:creationId xmlns:p14="http://schemas.microsoft.com/office/powerpoint/2010/main" val="2950061998"/>
+      </p:ext>
+    </p:extLst>
+  </p:cSld>
+  <p:clrMapOvr>
+    <a:masterClrMapping/>
+  </p:clrMapOvr>
+</p:sld>
+</file>
+
+<file path=ppt/slides/slide7.xml><?xml version="1.0" encoding="utf-8"?>
+<p:sld xmlns:a="http://schemas.openxmlformats.org/drawingml/2006/main" xmlns:r="http://schemas.openxmlformats.org/officeDocument/2006/relationships" xmlns:p="http://schemas.openxmlformats.org/presentationml/2006/main">
+  <p:cSld>
+    <p:spTree>
+      <p:nvGrpSpPr>
+        <p:cNvPr id="1" name="">
+          <a:extLst>
+            <a:ext uri="{FF2B5EF4-FFF2-40B4-BE49-F238E27FC236}">
+              <a16:creationId xmlns:a16="http://schemas.microsoft.com/office/drawing/2014/main" id="{64007FDD-F578-96F3-717C-B2F13D303536}"/>
+            </a:ext>
+          </a:extLst>
+        </p:cNvPr>
+        <p:cNvGrpSpPr/>
+        <p:nvPr/>
+      </p:nvGrpSpPr>
+      <p:grpSpPr>
+        <a:xfrm>
+          <a:off x="0" y="0"/>
+          <a:ext cx="0" cy="0"/>
+          <a:chOff x="0" y="0"/>
+          <a:chExt cx="0" cy="0"/>
+        </a:xfrm>
+      </p:grpSpPr>
+      <p:sp>
+        <p:nvSpPr>
+          <p:cNvPr id="2" name="Titel 1">
+            <a:extLst>
+              <a:ext uri="{FF2B5EF4-FFF2-40B4-BE49-F238E27FC236}">
+                <a16:creationId xmlns:a16="http://schemas.microsoft.com/office/drawing/2014/main" id="{2A3703A7-369E-1A90-7ABC-1FDCE42AF615}"/>
+              </a:ext>
+            </a:extLst>
+          </p:cNvPr>
+          <p:cNvSpPr>
+            <a:spLocks noGrp="1"/>
+          </p:cNvSpPr>
+          <p:nvPr>
+            <p:ph type="title"/>
+          </p:nvPr>
+        </p:nvSpPr>
+        <p:spPr/>
+        <p:txBody>
+          <a:bodyPr/>
+          <a:lstStyle/>
+          <a:p>
+            <a:r>
+              <a:rPr lang="de-DE" b="1" dirty="0">
+                <a:effectLst>
+                  <a:outerShdw blurRad="38100" dist="38100" dir="2700000" algn="tl">
+                    <a:srgbClr val="000000">
+                      <a:alpha val="43137"/>
+                    </a:srgbClr>
+                  </a:outerShdw>
+                </a:effectLst>
+              </a:rPr>
+              <a:t>Umsetzung</a:t>
+            </a:r>
+            <a:r>
+              <a:rPr lang="de-DE" dirty="0">
+                <a:effectLst>
+                  <a:outerShdw blurRad="38100" dist="38100" dir="2700000" algn="tl">
+                    <a:srgbClr val="000000">
+                      <a:alpha val="43137"/>
+                    </a:srgbClr>
+                  </a:outerShdw>
+                </a:effectLst>
+              </a:rPr>
+              <a:t> - Speicherung der Passwörter</a:t>
+            </a:r>
+            <a:endParaRPr lang="de-DE" u="sng" dirty="0">
+              <a:effectLst>
+                <a:outerShdw blurRad="38100" dist="38100" dir="2700000" algn="tl">
+                  <a:srgbClr val="000000">
+                    <a:alpha val="43137"/>
+                  </a:srgbClr>
+                </a:outerShdw>
+              </a:effectLst>
+            </a:endParaRPr>
+          </a:p>
+        </p:txBody>
+      </p:sp>
+      <p:sp>
+        <p:nvSpPr>
+          <p:cNvPr id="3" name="Inhaltsplatzhalter 2">
+            <a:extLst>
+              <a:ext uri="{FF2B5EF4-FFF2-40B4-BE49-F238E27FC236}">
+                <a16:creationId xmlns:a16="http://schemas.microsoft.com/office/drawing/2014/main" id="{99E85B5E-D0BE-DD00-27B5-D23F7A822FFA}"/>
+              </a:ext>
+            </a:extLst>
+          </p:cNvPr>
+          <p:cNvSpPr>
+            <a:spLocks noGrp="1"/>
+          </p:cNvSpPr>
+          <p:nvPr>
+            <p:ph idx="1"/>
+          </p:nvPr>
+        </p:nvSpPr>
+        <p:spPr/>
+        <p:txBody>
+          <a:bodyPr/>
+          <a:lstStyle/>
+          <a:p>
+            <a:r>
+              <a:rPr lang="de-DE" sz="1800" b="1" dirty="0"/>
+              <a:t>Allgemein:</a:t>
+            </a:r>
+          </a:p>
+          <a:p>
+            <a:pPr lvl="1"/>
+            <a:r>
+              <a:rPr lang="de-DE" sz="1400" b="1" dirty="0"/>
+              <a:t>Passwörter werden als Binär Datei abgespeichert</a:t>
+            </a:r>
+          </a:p>
+          <a:p>
+            <a:pPr lvl="1"/>
+            <a:r>
+              <a:rPr lang="de-DE" sz="1400" b="1" dirty="0"/>
+              <a:t>Ersten 16 Byte = Salt</a:t>
+            </a:r>
+          </a:p>
+          <a:p>
+            <a:pPr lvl="1"/>
+            <a:r>
+              <a:rPr lang="de-DE" sz="1400" b="1" dirty="0"/>
+              <a:t>Zweiten 16 Byte = IV (Initialisierungsvektor)</a:t>
+            </a:r>
+          </a:p>
+          <a:p>
+            <a:pPr lvl="1"/>
+            <a:r>
+              <a:rPr lang="de-DE" sz="1400" b="1" dirty="0"/>
+              <a:t>Rest = Daten (Passwörter)</a:t>
+            </a:r>
+          </a:p>
+        </p:txBody>
+      </p:sp>
+      <p:pic>
+        <p:nvPicPr>
+          <p:cNvPr id="31" name="Grafik 30" descr="Ein Bild, das Text, Screenshot, Schrift, Software enthält.&#10;&#10;KI-generierte Inhalte können fehlerhaft sein.">
+            <a:extLst>
+              <a:ext uri="{FF2B5EF4-FFF2-40B4-BE49-F238E27FC236}">
+                <a16:creationId xmlns:a16="http://schemas.microsoft.com/office/drawing/2014/main" id="{0CF0FEA1-D368-CF83-65CD-110854CC019E}"/>
+              </a:ext>
+            </a:extLst>
+          </p:cNvPr>
+          <p:cNvPicPr>
+            <a:picLocks noChangeAspect="1"/>
+          </p:cNvPicPr>
+          <p:nvPr/>
+        </p:nvPicPr>
+        <p:blipFill>
+          <a:blip r:embed="rId2">
+            <a:extLst>
+              <a:ext uri="{28A0092B-C50C-407E-A947-70E740481C1C}">
+                <a14:useLocalDpi xmlns:a14="http://schemas.microsoft.com/office/drawing/2010/main" val="0"/>
+              </a:ext>
+            </a:extLst>
+          </a:blip>
+          <a:stretch>
+            <a:fillRect/>
+          </a:stretch>
+        </p:blipFill>
+        <p:spPr>
+          <a:xfrm>
+            <a:off x="838200" y="3812550"/>
+            <a:ext cx="6745474" cy="2452900"/>
+          </a:xfrm>
+          <a:prstGeom prst="rect">
+            <a:avLst/>
+          </a:prstGeom>
+        </p:spPr>
+      </p:pic>
+      <p:pic>
+        <p:nvPicPr>
+          <p:cNvPr id="35" name="Grafik 34" descr="Ein Bild, das Text, Screenshot, Software, Schrift enthält.&#10;&#10;KI-generierte Inhalte können fehlerhaft sein.">
+            <a:extLst>
+              <a:ext uri="{FF2B5EF4-FFF2-40B4-BE49-F238E27FC236}">
+                <a16:creationId xmlns:a16="http://schemas.microsoft.com/office/drawing/2014/main" id="{CC675AC4-1CA5-8CA7-1015-F47AF164203F}"/>
+              </a:ext>
+            </a:extLst>
+          </p:cNvPr>
+          <p:cNvPicPr>
+            <a:picLocks noChangeAspect="1"/>
+          </p:cNvPicPr>
+          <p:nvPr/>
+        </p:nvPicPr>
+        <p:blipFill>
+          <a:blip r:embed="rId3">
+            <a:extLst>
+              <a:ext uri="{28A0092B-C50C-407E-A947-70E740481C1C}">
+                <a14:useLocalDpi xmlns:a14="http://schemas.microsoft.com/office/drawing/2010/main" val="0"/>
+              </a:ext>
+            </a:extLst>
+          </a:blip>
+          <a:stretch>
+            <a:fillRect/>
+          </a:stretch>
+        </p:blipFill>
+        <p:spPr>
+          <a:xfrm>
+            <a:off x="838200" y="3812550"/>
+            <a:ext cx="6745474" cy="2452900"/>
+          </a:xfrm>
+          <a:prstGeom prst="rect">
+            <a:avLst/>
+          </a:prstGeom>
+        </p:spPr>
+      </p:pic>
+      <p:pic>
+        <p:nvPicPr>
+          <p:cNvPr id="33" name="Grafik 32" descr="Ein Bild, das Text, Screenshot, Software, Schrift enthält.&#10;&#10;KI-generierte Inhalte können fehlerhaft sein.">
+            <a:extLst>
+              <a:ext uri="{FF2B5EF4-FFF2-40B4-BE49-F238E27FC236}">
+                <a16:creationId xmlns:a16="http://schemas.microsoft.com/office/drawing/2014/main" id="{A8E14C6D-8DEF-1B4D-E2D9-27A6C0763465}"/>
+              </a:ext>
+            </a:extLst>
+          </p:cNvPr>
+          <p:cNvPicPr>
+            <a:picLocks noChangeAspect="1"/>
+          </p:cNvPicPr>
+          <p:nvPr/>
+        </p:nvPicPr>
+        <p:blipFill>
+          <a:blip r:embed="rId4">
+            <a:extLst>
+              <a:ext uri="{28A0092B-C50C-407E-A947-70E740481C1C}">
+                <a14:useLocalDpi xmlns:a14="http://schemas.microsoft.com/office/drawing/2010/main" val="0"/>
+              </a:ext>
+            </a:extLst>
+          </a:blip>
+          <a:stretch>
+            <a:fillRect/>
+          </a:stretch>
+        </p:blipFill>
+        <p:spPr>
+          <a:xfrm>
+            <a:off x="838200" y="3812550"/>
+            <a:ext cx="6745474" cy="2452900"/>
+          </a:xfrm>
+          <a:prstGeom prst="rect">
+            <a:avLst/>
+          </a:prstGeom>
+        </p:spPr>
+      </p:pic>
+      <p:pic>
+        <p:nvPicPr>
+          <p:cNvPr id="37" name="Grafik 36" descr="Ein Bild, das Text, Screenshot, Software, Computersymbol enthält.&#10;&#10;KI-generierte Inhalte können fehlerhaft sein.">
+            <a:extLst>
+              <a:ext uri="{FF2B5EF4-FFF2-40B4-BE49-F238E27FC236}">
+                <a16:creationId xmlns:a16="http://schemas.microsoft.com/office/drawing/2014/main" id="{19336577-A2A4-1B24-6AD6-73E48FE8A3D5}"/>
+              </a:ext>
+            </a:extLst>
+          </p:cNvPr>
+          <p:cNvPicPr>
+            <a:picLocks noChangeAspect="1"/>
+          </p:cNvPicPr>
+          <p:nvPr/>
+        </p:nvPicPr>
+        <p:blipFill>
+          <a:blip r:embed="rId5">
+            <a:extLst>
+              <a:ext uri="{28A0092B-C50C-407E-A947-70E740481C1C}">
+                <a14:useLocalDpi xmlns:a14="http://schemas.microsoft.com/office/drawing/2010/main" val="0"/>
+              </a:ext>
+            </a:extLst>
+          </a:blip>
+          <a:stretch>
+            <a:fillRect/>
+          </a:stretch>
+        </p:blipFill>
+        <p:spPr>
+          <a:xfrm>
+            <a:off x="838200" y="3812551"/>
+            <a:ext cx="6745474" cy="2452899"/>
+          </a:xfrm>
+          <a:prstGeom prst="rect">
+            <a:avLst/>
+          </a:prstGeom>
+        </p:spPr>
+      </p:pic>
+    </p:spTree>
+    <p:extLst>
+      <p:ext uri="{BB962C8B-B14F-4D97-AF65-F5344CB8AC3E}">
+        <p14:creationId xmlns:p14="http://schemas.microsoft.com/office/powerpoint/2010/main" val="2673720107"/>
+      </p:ext>
+    </p:extLst>
+  </p:cSld>
+  <p:clrMapOvr>
+    <a:masterClrMapping/>
+  </p:clrMapOvr>
+  <p:timing>
+    <p:tnLst>
+      <p:par>
+        <p:cTn id="1" dur="indefinite" restart="never" nodeType="tmRoot">
+          <p:childTnLst>
+            <p:seq concurrent="1" nextAc="seek">
+              <p:cTn id="2" dur="indefinite" nodeType="mainSeq">
+                <p:childTnLst>
+                  <p:par>
+                    <p:cTn id="3" fill="hold">
+                      <p:stCondLst>
+                        <p:cond delay="indefinite"/>
+                      </p:stCondLst>
+                      <p:childTnLst>
+                        <p:par>
+                          <p:cTn id="4" fill="hold">
+                            <p:stCondLst>
+                              <p:cond delay="0"/>
+                            </p:stCondLst>
+                            <p:childTnLst>
+                              <p:par>
+                                <p:cTn id="5" presetID="1" presetClass="entr" presetSubtype="0" fill="hold" nodeType="clickEffect">
+                                  <p:stCondLst>
+                                    <p:cond delay="0"/>
+                                  </p:stCondLst>
+                                  <p:childTnLst>
+                                    <p:set>
+                                      <p:cBhvr>
+                                        <p:cTn id="6" dur="1" fill="hold">
+                                          <p:stCondLst>
+                                            <p:cond delay="0"/>
+                                          </p:stCondLst>
+                                        </p:cTn>
+                                        <p:tgtEl>
+                                          <p:spTgt spid="3">
+                                            <p:txEl>
+                                              <p:pRg st="2" end="2"/>
+                                            </p:txEl>
+                                          </p:spTgt>
+                                        </p:tgtEl>
+                                        <p:attrNameLst>
+                                          <p:attrName>style.visibility</p:attrName>
+                                        </p:attrNameLst>
+                                      </p:cBhvr>
+                                      <p:to>
+                                        <p:strVal val="visible"/>
+                                      </p:to>
+                                    </p:set>
+                                  </p:childTnLst>
+                                </p:cTn>
+                              </p:par>
+                              <p:par>
+                                <p:cTn id="7" presetID="1" presetClass="entr" presetSubtype="0" fill="hold" nodeType="withEffect">
+                                  <p:stCondLst>
+                                    <p:cond delay="0"/>
+                                  </p:stCondLst>
+                                  <p:childTnLst>
+                                    <p:set>
+                                      <p:cBhvr>
+                                        <p:cTn id="8" dur="1" fill="hold">
+                                          <p:stCondLst>
+                                            <p:cond delay="0"/>
+                                          </p:stCondLst>
+                                        </p:cTn>
+                                        <p:tgtEl>
+                                          <p:spTgt spid="35"/>
+                                        </p:tgtEl>
+                                        <p:attrNameLst>
+                                          <p:attrName>style.visibility</p:attrName>
+                                        </p:attrNameLst>
+                                      </p:cBhvr>
+                                      <p:to>
+                                        <p:strVal val="visible"/>
+                                      </p:to>
+                                    </p:set>
+                                  </p:childTnLst>
+                                </p:cTn>
+                              </p:par>
+                            </p:childTnLst>
+                          </p:cTn>
+                        </p:par>
+                      </p:childTnLst>
+                    </p:cTn>
+                  </p:par>
+                  <p:par>
+                    <p:cTn id="9" fill="hold">
+                      <p:stCondLst>
+                        <p:cond delay="indefinite"/>
+                      </p:stCondLst>
+                      <p:childTnLst>
+                        <p:par>
+                          <p:cTn id="10" fill="hold">
+                            <p:stCondLst>
+                              <p:cond delay="0"/>
+                            </p:stCondLst>
+                            <p:childTnLst>
+                              <p:par>
+                                <p:cTn id="11" presetID="1" presetClass="entr" presetSubtype="0" fill="hold" nodeType="clickEffect">
+                                  <p:stCondLst>
+                                    <p:cond delay="0"/>
+                                  </p:stCondLst>
+                                  <p:childTnLst>
+                                    <p:set>
+                                      <p:cBhvr>
+                                        <p:cTn id="12" dur="1" fill="hold">
+                                          <p:stCondLst>
+                                            <p:cond delay="0"/>
+                                          </p:stCondLst>
+                                        </p:cTn>
+                                        <p:tgtEl>
+                                          <p:spTgt spid="3">
+                                            <p:txEl>
+                                              <p:pRg st="3" end="3"/>
+                                            </p:txEl>
+                                          </p:spTgt>
+                                        </p:tgtEl>
+                                        <p:attrNameLst>
+                                          <p:attrName>style.visibility</p:attrName>
+                                        </p:attrNameLst>
+                                      </p:cBhvr>
+                                      <p:to>
+                                        <p:strVal val="visible"/>
+                                      </p:to>
+                                    </p:set>
+                                  </p:childTnLst>
+                                </p:cTn>
+                              </p:par>
+                              <p:par>
+                                <p:cTn id="13" presetID="1" presetClass="entr" presetSubtype="0" fill="hold" nodeType="withEffect">
+                                  <p:stCondLst>
+                                    <p:cond delay="0"/>
+                                  </p:stCondLst>
+                                  <p:childTnLst>
+                                    <p:set>
+                                      <p:cBhvr>
+                                        <p:cTn id="14" dur="1" fill="hold">
+                                          <p:stCondLst>
+                                            <p:cond delay="0"/>
+                                          </p:stCondLst>
+                                        </p:cTn>
+                                        <p:tgtEl>
+                                          <p:spTgt spid="33"/>
+                                        </p:tgtEl>
+                                        <p:attrNameLst>
+                                          <p:attrName>style.visibility</p:attrName>
+                                        </p:attrNameLst>
+                                      </p:cBhvr>
+                                      <p:to>
+                                        <p:strVal val="visible"/>
+                                      </p:to>
+                                    </p:set>
+                                  </p:childTnLst>
+                                </p:cTn>
+                              </p:par>
+                            </p:childTnLst>
+                          </p:cTn>
+                        </p:par>
+                      </p:childTnLst>
+                    </p:cTn>
+                  </p:par>
+                  <p:par>
+                    <p:cTn id="15" fill="hold">
+                      <p:stCondLst>
+                        <p:cond delay="indefinite"/>
+                      </p:stCondLst>
+                      <p:childTnLst>
+                        <p:par>
+                          <p:cTn id="16" fill="hold">
+                            <p:stCondLst>
+                              <p:cond delay="0"/>
+                            </p:stCondLst>
+                            <p:childTnLst>
+                              <p:par>
+                                <p:cTn id="17" presetID="1" presetClass="entr" presetSubtype="0" fill="hold" nodeType="clickEffect">
+                                  <p:stCondLst>
+                                    <p:cond delay="0"/>
+                                  </p:stCondLst>
+                                  <p:childTnLst>
+                                    <p:set>
+                                      <p:cBhvr>
+                                        <p:cTn id="18" dur="1" fill="hold">
+                                          <p:stCondLst>
+                                            <p:cond delay="0"/>
+                                          </p:stCondLst>
+                                        </p:cTn>
+                                        <p:tgtEl>
+                                          <p:spTgt spid="3">
+                                            <p:txEl>
+                                              <p:pRg st="4" end="4"/>
+                                            </p:txEl>
+                                          </p:spTgt>
+                                        </p:tgtEl>
+                                        <p:attrNameLst>
+                                          <p:attrName>style.visibility</p:attrName>
+                                        </p:attrNameLst>
+                                      </p:cBhvr>
+                                      <p:to>
+                                        <p:strVal val="visible"/>
+                                      </p:to>
+                                    </p:set>
+                                  </p:childTnLst>
+                                </p:cTn>
+                              </p:par>
+                              <p:par>
+                                <p:cTn id="19" presetID="1" presetClass="entr" presetSubtype="0" fill="hold" nodeType="withEffect">
+                                  <p:stCondLst>
+                                    <p:cond delay="0"/>
+                                  </p:stCondLst>
+                                  <p:childTnLst>
+                                    <p:set>
+                                      <p:cBhvr>
+                                        <p:cTn id="20" dur="1" fill="hold">
+                                          <p:stCondLst>
+                                            <p:cond delay="0"/>
+                                          </p:stCondLst>
+                                        </p:cTn>
+                                        <p:tgtEl>
+                                          <p:spTgt spid="37"/>
+                                        </p:tgtEl>
+                                        <p:attrNameLst>
+                                          <p:attrName>style.visibility</p:attrName>
+                                        </p:attrNameLst>
+                                      </p:cBhvr>
+                                      <p:to>
+                                        <p:strVal val="visible"/>
+                                      </p:to>
+                                    </p:set>
+                                  </p:childTnLst>
+                                </p:cTn>
+                              </p:par>
+                            </p:childTnLst>
+                          </p:cTn>
+                        </p:par>
+                      </p:childTnLst>
+                    </p:cTn>
+                  </p:par>
+                </p:childTnLst>
+              </p:cTn>
+              <p:prevCondLst>
+                <p:cond evt="onPrev" delay="0">
+                  <p:tgtEl>
+                    <p:sldTgt/>
+                  </p:tgtEl>
+                </p:cond>
+              </p:prevCondLst>
+              <p:nextCondLst>
+                <p:cond evt="onNext" delay="0">
+                  <p:tgtEl>
+                    <p:sldTgt/>
+                  </p:tgtEl>
+                </p:cond>
+              </p:nextCondLst>
+            </p:seq>
+          </p:childTnLst>
+        </p:cTn>
+      </p:par>
+    </p:tnLst>
+  </p:timing>
+</p:sld>
+</file>
+
+<file path=ppt/slides/slide8.xml><?xml version="1.0" encoding="utf-8"?>
+<p:sld xmlns:a="http://schemas.openxmlformats.org/drawingml/2006/main" xmlns:r="http://schemas.openxmlformats.org/officeDocument/2006/relationships" xmlns:p="http://schemas.openxmlformats.org/presentationml/2006/main">
+  <p:cSld>
+    <p:spTree>
+      <p:nvGrpSpPr>
         <p:cNvPr id="1" name=""/>
         <p:cNvGrpSpPr/>
         <p:nvPr/>
@@ -6408,43 +7142,55 @@
           <a:lstStyle/>
           <a:p>
             <a:r>
-              <a:rPr lang="de-DE" dirty="0" err="1"/>
-              <a:t>Lessions</a:t>
-            </a:r>
+              <a:rPr lang="de-DE" b="1" dirty="0">
+                <a:effectLst>
+                  <a:outerShdw blurRad="38100" dist="38100" dir="2700000" algn="tl">
+                    <a:srgbClr val="000000">
+                      <a:alpha val="43137"/>
+                    </a:srgbClr>
+                  </a:outerShdw>
+                </a:effectLst>
+              </a:rPr>
+              <a:t>Lessions Learned</a:t>
+            </a:r>
+          </a:p>
+        </p:txBody>
+      </p:sp>
+      <p:sp>
+        <p:nvSpPr>
+          <p:cNvPr id="3" name="Inhaltsplatzhalter 2">
+            <a:extLst>
+              <a:ext uri="{FF2B5EF4-FFF2-40B4-BE49-F238E27FC236}">
+                <a16:creationId xmlns:a16="http://schemas.microsoft.com/office/drawing/2014/main" id="{70B24FDD-F401-C7A6-98F6-6469FF9DFDB2}"/>
+              </a:ext>
+            </a:extLst>
+          </p:cNvPr>
+          <p:cNvSpPr>
+            <a:spLocks noGrp="1"/>
+          </p:cNvSpPr>
+          <p:nvPr>
+            <p:ph idx="1"/>
+          </p:nvPr>
+        </p:nvSpPr>
+        <p:spPr/>
+        <p:txBody>
+          <a:bodyPr/>
+          <a:lstStyle/>
+          <a:p>
             <a:r>
               <a:rPr lang="de-DE" dirty="0"/>
-              <a:t> </a:t>
-            </a:r>
-            <a:r>
-              <a:rPr lang="de-DE" dirty="0" err="1"/>
-              <a:t>Learned</a:t>
-            </a:r>
-            <a:endParaRPr lang="de-DE" dirty="0"/>
-          </a:p>
-        </p:txBody>
-      </p:sp>
-      <p:sp>
-        <p:nvSpPr>
-          <p:cNvPr id="3" name="Inhaltsplatzhalter 2">
-            <a:extLst>
-              <a:ext uri="{FF2B5EF4-FFF2-40B4-BE49-F238E27FC236}">
-                <a16:creationId xmlns:a16="http://schemas.microsoft.com/office/drawing/2014/main" id="{70B24FDD-F401-C7A6-98F6-6469FF9DFDB2}"/>
-              </a:ext>
-            </a:extLst>
-          </p:cNvPr>
-          <p:cNvSpPr>
-            <a:spLocks noGrp="1"/>
-          </p:cNvSpPr>
-          <p:nvPr>
-            <p:ph idx="1"/>
-          </p:nvPr>
-        </p:nvSpPr>
-        <p:spPr/>
-        <p:txBody>
-          <a:bodyPr/>
-          <a:lstStyle/>
-          <a:p>
-            <a:endParaRPr lang="de-DE"/>
+              <a:t>Vor dem Start überlegen</a:t>
+            </a:r>
+          </a:p>
+          <a:p>
+            <a:pPr lvl="1">
+              <a:buFont typeface="Wingdings" panose="05000000000000000000" pitchFamily="2" charset="2"/>
+              <a:buChar char="Ø"/>
+            </a:pPr>
+            <a:r>
+              <a:rPr lang="de-DE" dirty="0"/>
+              <a:t>Aufwändiger Umbau von Passwort-Speicherung in JSON-Datei als Klartext zu Binär Dateien</a:t>
+            </a:r>
           </a:p>
         </p:txBody>
       </p:sp>

</xml_diff>

<commit_message>
update PowerPoint: added jdbc driver
</commit_message>
<xml_diff>
--- a/pp/Presentation.pptx
+++ b/pp/Presentation.pptx
@@ -4605,7 +4605,7 @@
         <p:spPr/>
         <p:txBody>
           <a:bodyPr>
-            <a:normAutofit/>
+            <a:normAutofit lnSpcReduction="10000"/>
           </a:bodyPr>
           <a:lstStyle/>
           <a:p>
@@ -4639,6 +4639,12 @@
             <a:r>
               <a:rPr lang="de-DE" sz="2000" dirty="0"/>
               <a:t>Lombok Getter/Setter</a:t>
+            </a:r>
+          </a:p>
+          <a:p>
+            <a:r>
+              <a:rPr lang="de-DE" sz="2000" dirty="0"/>
+              <a:t>MySQL-Connector (JDBC-Driver)</a:t>
             </a:r>
           </a:p>
           <a:p>

</xml_diff>

<commit_message>
update PowerPoint: added settings window
</commit_message>
<xml_diff>
--- a/pp/Presentation.pptx
+++ b/pp/Presentation.pptx
@@ -9,11 +9,12 @@
     <p:sldId id="257" r:id="rId3"/>
     <p:sldId id="258" r:id="rId4"/>
     <p:sldId id="261" r:id="rId5"/>
-    <p:sldId id="259" r:id="rId6"/>
-    <p:sldId id="263" r:id="rId7"/>
-    <p:sldId id="262" r:id="rId8"/>
-    <p:sldId id="264" r:id="rId9"/>
-    <p:sldId id="260" r:id="rId10"/>
+    <p:sldId id="265" r:id="rId6"/>
+    <p:sldId id="259" r:id="rId7"/>
+    <p:sldId id="263" r:id="rId8"/>
+    <p:sldId id="262" r:id="rId9"/>
+    <p:sldId id="264" r:id="rId10"/>
+    <p:sldId id="260" r:id="rId11"/>
   </p:sldIdLst>
   <p:sldSz cx="12192000" cy="6858000"/>
   <p:notesSz cx="6858000" cy="9144000"/>
@@ -4533,6 +4534,110 @@
 </p:sld>
 </file>
 
+<file path=ppt/slides/slide10.xml><?xml version="1.0" encoding="utf-8"?>
+<p:sld xmlns:a="http://schemas.openxmlformats.org/drawingml/2006/main" xmlns:r="http://schemas.openxmlformats.org/officeDocument/2006/relationships" xmlns:p="http://schemas.openxmlformats.org/presentationml/2006/main">
+  <p:cSld>
+    <p:spTree>
+      <p:nvGrpSpPr>
+        <p:cNvPr id="1" name=""/>
+        <p:cNvGrpSpPr/>
+        <p:nvPr/>
+      </p:nvGrpSpPr>
+      <p:grpSpPr>
+        <a:xfrm>
+          <a:off x="0" y="0"/>
+          <a:ext cx="0" cy="0"/>
+          <a:chOff x="0" y="0"/>
+          <a:chExt cx="0" cy="0"/>
+        </a:xfrm>
+      </p:grpSpPr>
+      <p:sp>
+        <p:nvSpPr>
+          <p:cNvPr id="2" name="Titel 1">
+            <a:extLst>
+              <a:ext uri="{FF2B5EF4-FFF2-40B4-BE49-F238E27FC236}">
+                <a16:creationId xmlns:a16="http://schemas.microsoft.com/office/drawing/2014/main" id="{4777BA2B-6314-C13E-8020-90F8CA35B0C6}"/>
+              </a:ext>
+            </a:extLst>
+          </p:cNvPr>
+          <p:cNvSpPr>
+            <a:spLocks noGrp="1"/>
+          </p:cNvSpPr>
+          <p:nvPr>
+            <p:ph type="title"/>
+          </p:nvPr>
+        </p:nvSpPr>
+        <p:spPr/>
+        <p:txBody>
+          <a:bodyPr/>
+          <a:lstStyle/>
+          <a:p>
+            <a:r>
+              <a:rPr lang="de-DE" b="1" dirty="0">
+                <a:effectLst>
+                  <a:outerShdw blurRad="38100" dist="38100" dir="2700000" algn="tl">
+                    <a:srgbClr val="000000">
+                      <a:alpha val="43137"/>
+                    </a:srgbClr>
+                  </a:outerShdw>
+                </a:effectLst>
+              </a:rPr>
+              <a:t>Lessions Learned</a:t>
+            </a:r>
+          </a:p>
+        </p:txBody>
+      </p:sp>
+      <p:sp>
+        <p:nvSpPr>
+          <p:cNvPr id="3" name="Inhaltsplatzhalter 2">
+            <a:extLst>
+              <a:ext uri="{FF2B5EF4-FFF2-40B4-BE49-F238E27FC236}">
+                <a16:creationId xmlns:a16="http://schemas.microsoft.com/office/drawing/2014/main" id="{70B24FDD-F401-C7A6-98F6-6469FF9DFDB2}"/>
+              </a:ext>
+            </a:extLst>
+          </p:cNvPr>
+          <p:cNvSpPr>
+            <a:spLocks noGrp="1"/>
+          </p:cNvSpPr>
+          <p:nvPr>
+            <p:ph idx="1"/>
+          </p:nvPr>
+        </p:nvSpPr>
+        <p:spPr/>
+        <p:txBody>
+          <a:bodyPr/>
+          <a:lstStyle/>
+          <a:p>
+            <a:r>
+              <a:rPr lang="de-DE" dirty="0"/>
+              <a:t>Vor dem Start überlegen</a:t>
+            </a:r>
+          </a:p>
+          <a:p>
+            <a:pPr lvl="1">
+              <a:buFont typeface="Wingdings" panose="05000000000000000000" pitchFamily="2" charset="2"/>
+              <a:buChar char="Ø"/>
+            </a:pPr>
+            <a:r>
+              <a:rPr lang="de-DE" dirty="0"/>
+              <a:t>Aufwändiger Umbau von Passwort-Speicherung in JSON-Datei als Klartext zu Binär Dateien</a:t>
+            </a:r>
+          </a:p>
+        </p:txBody>
+      </p:sp>
+    </p:spTree>
+    <p:extLst>
+      <p:ext uri="{BB962C8B-B14F-4D97-AF65-F5344CB8AC3E}">
+        <p14:creationId xmlns:p14="http://schemas.microsoft.com/office/powerpoint/2010/main" val="3553515808"/>
+      </p:ext>
+    </p:extLst>
+  </p:cSld>
+  <p:clrMapOvr>
+    <a:masterClrMapping/>
+  </p:clrMapOvr>
+</p:sld>
+</file>
+
 <file path=ppt/slides/slide2.xml><?xml version="1.0" encoding="utf-8"?>
 <p:sld xmlns:a="http://schemas.openxmlformats.org/drawingml/2006/main" xmlns:r="http://schemas.openxmlformats.org/officeDocument/2006/relationships" xmlns:p="http://schemas.openxmlformats.org/presentationml/2006/main">
   <p:cSld>
@@ -6337,6 +6442,138 @@
   <p:cSld>
     <p:spTree>
       <p:nvGrpSpPr>
+        <p:cNvPr id="1" name="">
+          <a:extLst>
+            <a:ext uri="{FF2B5EF4-FFF2-40B4-BE49-F238E27FC236}">
+              <a16:creationId xmlns:a16="http://schemas.microsoft.com/office/drawing/2014/main" id="{E5802E7C-6FFF-C082-1FFE-A4950742F91B}"/>
+            </a:ext>
+          </a:extLst>
+        </p:cNvPr>
+        <p:cNvGrpSpPr/>
+        <p:nvPr/>
+      </p:nvGrpSpPr>
+      <p:grpSpPr>
+        <a:xfrm>
+          <a:off x="0" y="0"/>
+          <a:ext cx="0" cy="0"/>
+          <a:chOff x="0" y="0"/>
+          <a:chExt cx="0" cy="0"/>
+        </a:xfrm>
+      </p:grpSpPr>
+      <p:sp>
+        <p:nvSpPr>
+          <p:cNvPr id="2" name="Titel 1">
+            <a:extLst>
+              <a:ext uri="{FF2B5EF4-FFF2-40B4-BE49-F238E27FC236}">
+                <a16:creationId xmlns:a16="http://schemas.microsoft.com/office/drawing/2014/main" id="{23CFA9F2-8837-E5B6-8425-5CC48C8FD2BD}"/>
+              </a:ext>
+            </a:extLst>
+          </p:cNvPr>
+          <p:cNvSpPr>
+            <a:spLocks noGrp="1"/>
+          </p:cNvSpPr>
+          <p:nvPr>
+            <p:ph type="title"/>
+          </p:nvPr>
+        </p:nvSpPr>
+        <p:spPr/>
+        <p:txBody>
+          <a:bodyPr/>
+          <a:lstStyle/>
+          <a:p>
+            <a:r>
+              <a:rPr lang="de-DE" b="1" dirty="0">
+                <a:effectLst>
+                  <a:outerShdw blurRad="38100" dist="38100" dir="2700000" algn="tl">
+                    <a:srgbClr val="000000">
+                      <a:alpha val="43137"/>
+                    </a:srgbClr>
+                  </a:outerShdw>
+                </a:effectLst>
+              </a:rPr>
+              <a:t>Technischer Hintergrund</a:t>
+            </a:r>
+          </a:p>
+        </p:txBody>
+      </p:sp>
+      <p:sp>
+        <p:nvSpPr>
+          <p:cNvPr id="3" name="Inhaltsplatzhalter 2">
+            <a:extLst>
+              <a:ext uri="{FF2B5EF4-FFF2-40B4-BE49-F238E27FC236}">
+                <a16:creationId xmlns:a16="http://schemas.microsoft.com/office/drawing/2014/main" id="{06038C3A-873E-3845-090C-C8FA4418AB6E}"/>
+              </a:ext>
+            </a:extLst>
+          </p:cNvPr>
+          <p:cNvSpPr>
+            <a:spLocks noGrp="1"/>
+          </p:cNvSpPr>
+          <p:nvPr>
+            <p:ph idx="1"/>
+          </p:nvPr>
+        </p:nvSpPr>
+        <p:spPr/>
+        <p:txBody>
+          <a:bodyPr>
+            <a:normAutofit/>
+          </a:bodyPr>
+          <a:lstStyle/>
+          <a:p>
+            <a:r>
+              <a:rPr lang="de-DE" sz="2000" b="1" dirty="0"/>
+              <a:t>Einstellungen:</a:t>
+            </a:r>
+          </a:p>
+        </p:txBody>
+      </p:sp>
+      <p:pic>
+        <p:nvPicPr>
+          <p:cNvPr id="5" name="Grafik 4">
+            <a:extLst>
+              <a:ext uri="{FF2B5EF4-FFF2-40B4-BE49-F238E27FC236}">
+                <a16:creationId xmlns:a16="http://schemas.microsoft.com/office/drawing/2014/main" id="{38204D75-5CF4-B051-2DCA-7269A90283A6}"/>
+              </a:ext>
+            </a:extLst>
+          </p:cNvPr>
+          <p:cNvPicPr>
+            <a:picLocks noChangeAspect="1"/>
+          </p:cNvPicPr>
+          <p:nvPr/>
+        </p:nvPicPr>
+        <p:blipFill>
+          <a:blip r:embed="rId2"/>
+          <a:stretch>
+            <a:fillRect/>
+          </a:stretch>
+        </p:blipFill>
+        <p:spPr>
+          <a:xfrm>
+            <a:off x="6096000" y="2636707"/>
+            <a:ext cx="4069454" cy="2729173"/>
+          </a:xfrm>
+          <a:prstGeom prst="rect">
+            <a:avLst/>
+          </a:prstGeom>
+        </p:spPr>
+      </p:pic>
+    </p:spTree>
+    <p:extLst>
+      <p:ext uri="{BB962C8B-B14F-4D97-AF65-F5344CB8AC3E}">
+        <p14:creationId xmlns:p14="http://schemas.microsoft.com/office/powerpoint/2010/main" val="2816906569"/>
+      </p:ext>
+    </p:extLst>
+  </p:cSld>
+  <p:clrMapOvr>
+    <a:masterClrMapping/>
+  </p:clrMapOvr>
+</p:sld>
+</file>
+
+<file path=ppt/slides/slide6.xml><?xml version="1.0" encoding="utf-8"?>
+<p:sld xmlns:a="http://schemas.openxmlformats.org/drawingml/2006/main" xmlns:r="http://schemas.openxmlformats.org/officeDocument/2006/relationships" xmlns:p="http://schemas.openxmlformats.org/presentationml/2006/main">
+  <p:cSld>
+    <p:spTree>
+      <p:nvGrpSpPr>
         <p:cNvPr id="1" name=""/>
         <p:cNvGrpSpPr/>
         <p:nvPr/>
@@ -6444,7 +6681,7 @@
 </p:sld>
 </file>
 
-<file path=ppt/slides/slide6.xml><?xml version="1.0" encoding="utf-8"?>
+<file path=ppt/slides/slide7.xml><?xml version="1.0" encoding="utf-8"?>
 <p:sld xmlns:a="http://schemas.openxmlformats.org/drawingml/2006/main" xmlns:r="http://schemas.openxmlformats.org/officeDocument/2006/relationships" xmlns:p="http://schemas.openxmlformats.org/presentationml/2006/main">
   <p:cSld>
     <p:spTree>
@@ -6559,7 +6796,7 @@
 </p:sld>
 </file>
 
-<file path=ppt/slides/slide7.xml><?xml version="1.0" encoding="utf-8"?>
+<file path=ppt/slides/slide8.xml><?xml version="1.0" encoding="utf-8"?>
 <p:sld xmlns:a="http://schemas.openxmlformats.org/drawingml/2006/main" xmlns:r="http://schemas.openxmlformats.org/officeDocument/2006/relationships" xmlns:p="http://schemas.openxmlformats.org/presentationml/2006/main">
   <p:cSld>
     <p:spTree>
@@ -7110,7 +7347,7 @@
 </p:sld>
 </file>
 
-<file path=ppt/slides/slide8.xml><?xml version="1.0" encoding="utf-8"?>
+<file path=ppt/slides/slide9.xml><?xml version="1.0" encoding="utf-8"?>
 <p:sld xmlns:a="http://schemas.openxmlformats.org/drawingml/2006/main" xmlns:r="http://schemas.openxmlformats.org/officeDocument/2006/relationships" xmlns:p="http://schemas.openxmlformats.org/presentationml/2006/main">
   <p:cSld>
     <p:spTree>
@@ -7229,110 +7466,6 @@
     <p:extLst>
       <p:ext uri="{BB962C8B-B14F-4D97-AF65-F5344CB8AC3E}">
         <p14:creationId xmlns:p14="http://schemas.microsoft.com/office/powerpoint/2010/main" val="3903202141"/>
-      </p:ext>
-    </p:extLst>
-  </p:cSld>
-  <p:clrMapOvr>
-    <a:masterClrMapping/>
-  </p:clrMapOvr>
-</p:sld>
-</file>
-
-<file path=ppt/slides/slide9.xml><?xml version="1.0" encoding="utf-8"?>
-<p:sld xmlns:a="http://schemas.openxmlformats.org/drawingml/2006/main" xmlns:r="http://schemas.openxmlformats.org/officeDocument/2006/relationships" xmlns:p="http://schemas.openxmlformats.org/presentationml/2006/main">
-  <p:cSld>
-    <p:spTree>
-      <p:nvGrpSpPr>
-        <p:cNvPr id="1" name=""/>
-        <p:cNvGrpSpPr/>
-        <p:nvPr/>
-      </p:nvGrpSpPr>
-      <p:grpSpPr>
-        <a:xfrm>
-          <a:off x="0" y="0"/>
-          <a:ext cx="0" cy="0"/>
-          <a:chOff x="0" y="0"/>
-          <a:chExt cx="0" cy="0"/>
-        </a:xfrm>
-      </p:grpSpPr>
-      <p:sp>
-        <p:nvSpPr>
-          <p:cNvPr id="2" name="Titel 1">
-            <a:extLst>
-              <a:ext uri="{FF2B5EF4-FFF2-40B4-BE49-F238E27FC236}">
-                <a16:creationId xmlns:a16="http://schemas.microsoft.com/office/drawing/2014/main" id="{4777BA2B-6314-C13E-8020-90F8CA35B0C6}"/>
-              </a:ext>
-            </a:extLst>
-          </p:cNvPr>
-          <p:cNvSpPr>
-            <a:spLocks noGrp="1"/>
-          </p:cNvSpPr>
-          <p:nvPr>
-            <p:ph type="title"/>
-          </p:nvPr>
-        </p:nvSpPr>
-        <p:spPr/>
-        <p:txBody>
-          <a:bodyPr/>
-          <a:lstStyle/>
-          <a:p>
-            <a:r>
-              <a:rPr lang="de-DE" b="1" dirty="0">
-                <a:effectLst>
-                  <a:outerShdw blurRad="38100" dist="38100" dir="2700000" algn="tl">
-                    <a:srgbClr val="000000">
-                      <a:alpha val="43137"/>
-                    </a:srgbClr>
-                  </a:outerShdw>
-                </a:effectLst>
-              </a:rPr>
-              <a:t>Lessions Learned</a:t>
-            </a:r>
-          </a:p>
-        </p:txBody>
-      </p:sp>
-      <p:sp>
-        <p:nvSpPr>
-          <p:cNvPr id="3" name="Inhaltsplatzhalter 2">
-            <a:extLst>
-              <a:ext uri="{FF2B5EF4-FFF2-40B4-BE49-F238E27FC236}">
-                <a16:creationId xmlns:a16="http://schemas.microsoft.com/office/drawing/2014/main" id="{70B24FDD-F401-C7A6-98F6-6469FF9DFDB2}"/>
-              </a:ext>
-            </a:extLst>
-          </p:cNvPr>
-          <p:cNvSpPr>
-            <a:spLocks noGrp="1"/>
-          </p:cNvSpPr>
-          <p:nvPr>
-            <p:ph idx="1"/>
-          </p:nvPr>
-        </p:nvSpPr>
-        <p:spPr/>
-        <p:txBody>
-          <a:bodyPr/>
-          <a:lstStyle/>
-          <a:p>
-            <a:r>
-              <a:rPr lang="de-DE" dirty="0"/>
-              <a:t>Vor dem Start überlegen</a:t>
-            </a:r>
-          </a:p>
-          <a:p>
-            <a:pPr lvl="1">
-              <a:buFont typeface="Wingdings" panose="05000000000000000000" pitchFamily="2" charset="2"/>
-              <a:buChar char="Ø"/>
-            </a:pPr>
-            <a:r>
-              <a:rPr lang="de-DE" dirty="0"/>
-              <a:t>Aufwändiger Umbau von Passwort-Speicherung in JSON-Datei als Klartext zu Binär Dateien</a:t>
-            </a:r>
-          </a:p>
-        </p:txBody>
-      </p:sp>
-    </p:spTree>
-    <p:extLst>
-      <p:ext uri="{BB962C8B-B14F-4D97-AF65-F5344CB8AC3E}">
-        <p14:creationId xmlns:p14="http://schemas.microsoft.com/office/powerpoint/2010/main" val="3553515808"/>
       </p:ext>
     </p:extLst>
   </p:cSld>

</xml_diff>

<commit_message>
update PowerPoint: added Diagrams
</commit_message>
<xml_diff>
--- a/pp/Presentation.pptx
+++ b/pp/Presentation.pptx
@@ -11,10 +11,12 @@
     <p:sldId id="261" r:id="rId5"/>
     <p:sldId id="265" r:id="rId6"/>
     <p:sldId id="259" r:id="rId7"/>
-    <p:sldId id="263" r:id="rId8"/>
-    <p:sldId id="262" r:id="rId9"/>
-    <p:sldId id="264" r:id="rId10"/>
-    <p:sldId id="260" r:id="rId11"/>
+    <p:sldId id="266" r:id="rId8"/>
+    <p:sldId id="263" r:id="rId9"/>
+    <p:sldId id="267" r:id="rId10"/>
+    <p:sldId id="262" r:id="rId11"/>
+    <p:sldId id="264" r:id="rId12"/>
+    <p:sldId id="260" r:id="rId13"/>
   </p:sldIdLst>
   <p:sldSz cx="12192000" cy="6858000"/>
   <p:notesSz cx="6858000" cy="9144000"/>
@@ -4539,6 +4541,835 @@
   <p:cSld>
     <p:spTree>
       <p:nvGrpSpPr>
+        <p:cNvPr id="1" name="">
+          <a:extLst>
+            <a:ext uri="{FF2B5EF4-FFF2-40B4-BE49-F238E27FC236}">
+              <a16:creationId xmlns:a16="http://schemas.microsoft.com/office/drawing/2014/main" id="{64007FDD-F578-96F3-717C-B2F13D303536}"/>
+            </a:ext>
+          </a:extLst>
+        </p:cNvPr>
+        <p:cNvGrpSpPr/>
+        <p:nvPr/>
+      </p:nvGrpSpPr>
+      <p:grpSpPr>
+        <a:xfrm>
+          <a:off x="0" y="0"/>
+          <a:ext cx="0" cy="0"/>
+          <a:chOff x="0" y="0"/>
+          <a:chExt cx="0" cy="0"/>
+        </a:xfrm>
+      </p:grpSpPr>
+      <p:sp>
+        <p:nvSpPr>
+          <p:cNvPr id="25" name="Rechteck 24">
+            <a:extLst>
+              <a:ext uri="{FF2B5EF4-FFF2-40B4-BE49-F238E27FC236}">
+                <a16:creationId xmlns:a16="http://schemas.microsoft.com/office/drawing/2014/main" id="{55A0F817-D821-373B-0FB5-9512CEE84DF7}"/>
+              </a:ext>
+            </a:extLst>
+          </p:cNvPr>
+          <p:cNvSpPr/>
+          <p:nvPr/>
+        </p:nvSpPr>
+        <p:spPr>
+          <a:xfrm>
+            <a:off x="448310" y="1734710"/>
+            <a:ext cx="4237990" cy="5024230"/>
+          </a:xfrm>
+          <a:prstGeom prst="rect">
+            <a:avLst/>
+          </a:prstGeom>
+          <a:solidFill>
+            <a:schemeClr val="accent4">
+              <a:lumMod val="40000"/>
+              <a:lumOff val="60000"/>
+            </a:schemeClr>
+          </a:solidFill>
+        </p:spPr>
+        <p:style>
+          <a:lnRef idx="2">
+            <a:schemeClr val="accent4">
+              <a:shade val="15000"/>
+            </a:schemeClr>
+          </a:lnRef>
+          <a:fillRef idx="1">
+            <a:schemeClr val="accent4"/>
+          </a:fillRef>
+          <a:effectRef idx="0">
+            <a:schemeClr val="accent4"/>
+          </a:effectRef>
+          <a:fontRef idx="minor">
+            <a:schemeClr val="lt1"/>
+          </a:fontRef>
+        </p:style>
+        <p:txBody>
+          <a:bodyPr rtlCol="0" anchor="t"/>
+          <a:lstStyle/>
+          <a:p>
+            <a:r>
+              <a:rPr lang="de-DE" dirty="0">
+                <a:solidFill>
+                  <a:schemeClr val="tx2">
+                    <a:lumMod val="75000"/>
+                    <a:lumOff val="25000"/>
+                  </a:schemeClr>
+                </a:solidFill>
+              </a:rPr>
+              <a:t>Passwortmanager</a:t>
+            </a:r>
+          </a:p>
+        </p:txBody>
+      </p:sp>
+      <p:sp>
+        <p:nvSpPr>
+          <p:cNvPr id="2" name="Titel 1">
+            <a:extLst>
+              <a:ext uri="{FF2B5EF4-FFF2-40B4-BE49-F238E27FC236}">
+                <a16:creationId xmlns:a16="http://schemas.microsoft.com/office/drawing/2014/main" id="{2A3703A7-369E-1A90-7ABC-1FDCE42AF615}"/>
+              </a:ext>
+            </a:extLst>
+          </p:cNvPr>
+          <p:cNvSpPr>
+            <a:spLocks noGrp="1"/>
+          </p:cNvSpPr>
+          <p:nvPr>
+            <p:ph type="title"/>
+          </p:nvPr>
+        </p:nvSpPr>
+        <p:spPr/>
+        <p:txBody>
+          <a:bodyPr/>
+          <a:lstStyle/>
+          <a:p>
+            <a:r>
+              <a:rPr lang="de-DE" b="1" dirty="0">
+                <a:effectLst>
+                  <a:outerShdw blurRad="38100" dist="38100" dir="2700000" algn="tl">
+                    <a:srgbClr val="000000">
+                      <a:alpha val="43137"/>
+                    </a:srgbClr>
+                  </a:outerShdw>
+                </a:effectLst>
+              </a:rPr>
+              <a:t>Umsetzung</a:t>
+            </a:r>
+            <a:r>
+              <a:rPr lang="de-DE" dirty="0">
+                <a:effectLst>
+                  <a:outerShdw blurRad="38100" dist="38100" dir="2700000" algn="tl">
+                    <a:srgbClr val="000000">
+                      <a:alpha val="43137"/>
+                    </a:srgbClr>
+                  </a:outerShdw>
+                </a:effectLst>
+              </a:rPr>
+              <a:t> - Speicherung der Passwörter (Server)</a:t>
+            </a:r>
+            <a:endParaRPr lang="de-DE" u="sng" dirty="0">
+              <a:effectLst>
+                <a:outerShdw blurRad="38100" dist="38100" dir="2700000" algn="tl">
+                  <a:srgbClr val="000000">
+                    <a:alpha val="43137"/>
+                  </a:srgbClr>
+                </a:outerShdw>
+              </a:effectLst>
+            </a:endParaRPr>
+          </a:p>
+        </p:txBody>
+      </p:sp>
+      <p:sp>
+        <p:nvSpPr>
+          <p:cNvPr id="5" name="Rechteck 4">
+            <a:extLst>
+              <a:ext uri="{FF2B5EF4-FFF2-40B4-BE49-F238E27FC236}">
+                <a16:creationId xmlns:a16="http://schemas.microsoft.com/office/drawing/2014/main" id="{7E894043-D3EA-9303-9B47-B297F2DC5D72}"/>
+              </a:ext>
+            </a:extLst>
+          </p:cNvPr>
+          <p:cNvSpPr/>
+          <p:nvPr/>
+        </p:nvSpPr>
+        <p:spPr>
+          <a:xfrm>
+            <a:off x="844550" y="2933700"/>
+            <a:ext cx="2287270" cy="3765550"/>
+          </a:xfrm>
+          <a:prstGeom prst="rect">
+            <a:avLst/>
+          </a:prstGeom>
+        </p:spPr>
+        <p:style>
+          <a:lnRef idx="2">
+            <a:schemeClr val="accent4">
+              <a:shade val="15000"/>
+            </a:schemeClr>
+          </a:lnRef>
+          <a:fillRef idx="1">
+            <a:schemeClr val="accent4"/>
+          </a:fillRef>
+          <a:effectRef idx="0">
+            <a:schemeClr val="accent4"/>
+          </a:effectRef>
+          <a:fontRef idx="minor">
+            <a:schemeClr val="lt1"/>
+          </a:fontRef>
+        </p:style>
+        <p:txBody>
+          <a:bodyPr rtlCol="0" anchor="t"/>
+          <a:lstStyle/>
+          <a:p>
+            <a:r>
+              <a:rPr lang="de-DE" dirty="0"/>
+              <a:t>Datei / BLOB</a:t>
+            </a:r>
+          </a:p>
+        </p:txBody>
+      </p:sp>
+      <p:sp>
+        <p:nvSpPr>
+          <p:cNvPr id="6" name="Rechteck 5">
+            <a:extLst>
+              <a:ext uri="{FF2B5EF4-FFF2-40B4-BE49-F238E27FC236}">
+                <a16:creationId xmlns:a16="http://schemas.microsoft.com/office/drawing/2014/main" id="{BF8534E5-71D2-F6C8-77D7-696964BB819D}"/>
+              </a:ext>
+            </a:extLst>
+          </p:cNvPr>
+          <p:cNvSpPr/>
+          <p:nvPr/>
+        </p:nvSpPr>
+        <p:spPr>
+          <a:xfrm>
+            <a:off x="1201762" y="3310066"/>
+            <a:ext cx="1692069" cy="343462"/>
+          </a:xfrm>
+          <a:prstGeom prst="rect">
+            <a:avLst/>
+          </a:prstGeom>
+        </p:spPr>
+        <p:style>
+          <a:lnRef idx="2">
+            <a:schemeClr val="accent1">
+              <a:shade val="15000"/>
+            </a:schemeClr>
+          </a:lnRef>
+          <a:fillRef idx="1">
+            <a:schemeClr val="accent1"/>
+          </a:fillRef>
+          <a:effectRef idx="0">
+            <a:schemeClr val="accent1"/>
+          </a:effectRef>
+          <a:fontRef idx="minor">
+            <a:schemeClr val="lt1"/>
+          </a:fontRef>
+        </p:style>
+        <p:txBody>
+          <a:bodyPr rtlCol="0" anchor="ctr"/>
+          <a:lstStyle/>
+          <a:p>
+            <a:pPr algn="ctr"/>
+            <a:r>
+              <a:rPr lang="de-DE" dirty="0"/>
+              <a:t>Salt</a:t>
+            </a:r>
+          </a:p>
+        </p:txBody>
+      </p:sp>
+      <p:sp>
+        <p:nvSpPr>
+          <p:cNvPr id="7" name="Rechteck 6">
+            <a:extLst>
+              <a:ext uri="{FF2B5EF4-FFF2-40B4-BE49-F238E27FC236}">
+                <a16:creationId xmlns:a16="http://schemas.microsoft.com/office/drawing/2014/main" id="{B08F3FCA-539C-5F26-6BC3-B6907F9643DA}"/>
+              </a:ext>
+            </a:extLst>
+          </p:cNvPr>
+          <p:cNvSpPr/>
+          <p:nvPr/>
+        </p:nvSpPr>
+        <p:spPr>
+          <a:xfrm>
+            <a:off x="1200150" y="3760805"/>
+            <a:ext cx="1693682" cy="343462"/>
+          </a:xfrm>
+          <a:prstGeom prst="rect">
+            <a:avLst/>
+          </a:prstGeom>
+        </p:spPr>
+        <p:style>
+          <a:lnRef idx="2">
+            <a:schemeClr val="accent1">
+              <a:shade val="15000"/>
+            </a:schemeClr>
+          </a:lnRef>
+          <a:fillRef idx="1">
+            <a:schemeClr val="accent1"/>
+          </a:fillRef>
+          <a:effectRef idx="0">
+            <a:schemeClr val="accent1"/>
+          </a:effectRef>
+          <a:fontRef idx="minor">
+            <a:schemeClr val="lt1"/>
+          </a:fontRef>
+        </p:style>
+        <p:txBody>
+          <a:bodyPr rtlCol="0" anchor="ctr"/>
+          <a:lstStyle/>
+          <a:p>
+            <a:pPr algn="ctr"/>
+            <a:r>
+              <a:rPr lang="de-DE" dirty="0"/>
+              <a:t>IV</a:t>
+            </a:r>
+          </a:p>
+        </p:txBody>
+      </p:sp>
+      <p:sp>
+        <p:nvSpPr>
+          <p:cNvPr id="8" name="Rechteck 7">
+            <a:extLst>
+              <a:ext uri="{FF2B5EF4-FFF2-40B4-BE49-F238E27FC236}">
+                <a16:creationId xmlns:a16="http://schemas.microsoft.com/office/drawing/2014/main" id="{43A3DAAC-5BB9-26F6-1080-3F52015CE3C5}"/>
+              </a:ext>
+            </a:extLst>
+          </p:cNvPr>
+          <p:cNvSpPr/>
+          <p:nvPr/>
+        </p:nvSpPr>
+        <p:spPr>
+          <a:xfrm>
+            <a:off x="1200150" y="4247388"/>
+            <a:ext cx="1693682" cy="2280411"/>
+          </a:xfrm>
+          <a:prstGeom prst="rect">
+            <a:avLst/>
+          </a:prstGeom>
+        </p:spPr>
+        <p:style>
+          <a:lnRef idx="2">
+            <a:schemeClr val="accent1">
+              <a:shade val="15000"/>
+            </a:schemeClr>
+          </a:lnRef>
+          <a:fillRef idx="1">
+            <a:schemeClr val="accent1"/>
+          </a:fillRef>
+          <a:effectRef idx="0">
+            <a:schemeClr val="accent1"/>
+          </a:effectRef>
+          <a:fontRef idx="minor">
+            <a:schemeClr val="lt1"/>
+          </a:fontRef>
+        </p:style>
+        <p:txBody>
+          <a:bodyPr rtlCol="0" anchor="ctr"/>
+          <a:lstStyle/>
+          <a:p>
+            <a:pPr algn="ctr"/>
+            <a:r>
+              <a:rPr lang="de-DE" dirty="0"/>
+              <a:t>Verschlüsselte</a:t>
+            </a:r>
+          </a:p>
+          <a:p>
+            <a:pPr algn="ctr"/>
+            <a:r>
+              <a:rPr lang="de-DE" dirty="0"/>
+              <a:t>Daten</a:t>
+            </a:r>
+          </a:p>
+        </p:txBody>
+      </p:sp>
+      <p:cxnSp>
+        <p:nvCxnSpPr>
+          <p:cNvPr id="11" name="Gerade Verbindung mit Pfeil 10">
+            <a:extLst>
+              <a:ext uri="{FF2B5EF4-FFF2-40B4-BE49-F238E27FC236}">
+                <a16:creationId xmlns:a16="http://schemas.microsoft.com/office/drawing/2014/main" id="{620EF59F-733A-4D24-E3C7-632F07E51557}"/>
+              </a:ext>
+            </a:extLst>
+          </p:cNvPr>
+          <p:cNvCxnSpPr>
+            <a:cxnSpLocks/>
+          </p:cNvCxnSpPr>
+          <p:nvPr/>
+        </p:nvCxnSpPr>
+        <p:spPr>
+          <a:xfrm>
+            <a:off x="4686300" y="4254166"/>
+            <a:ext cx="2689860" cy="0"/>
+          </a:xfrm>
+          <a:prstGeom prst="straightConnector1">
+            <a:avLst/>
+          </a:prstGeom>
+          <a:ln w="57150">
+            <a:tailEnd type="triangle"/>
+          </a:ln>
+        </p:spPr>
+        <p:style>
+          <a:lnRef idx="2">
+            <a:schemeClr val="accent6"/>
+          </a:lnRef>
+          <a:fillRef idx="0">
+            <a:schemeClr val="accent6"/>
+          </a:fillRef>
+          <a:effectRef idx="1">
+            <a:schemeClr val="accent6"/>
+          </a:effectRef>
+          <a:fontRef idx="minor">
+            <a:schemeClr val="tx1"/>
+          </a:fontRef>
+        </p:style>
+      </p:cxnSp>
+      <p:sp>
+        <p:nvSpPr>
+          <p:cNvPr id="13" name="Textfeld 12">
+            <a:extLst>
+              <a:ext uri="{FF2B5EF4-FFF2-40B4-BE49-F238E27FC236}">
+                <a16:creationId xmlns:a16="http://schemas.microsoft.com/office/drawing/2014/main" id="{E2C27403-A117-1793-4E41-CDD43497EBDC}"/>
+              </a:ext>
+            </a:extLst>
+          </p:cNvPr>
+          <p:cNvSpPr txBox="1"/>
+          <p:nvPr/>
+        </p:nvSpPr>
+        <p:spPr>
+          <a:xfrm>
+            <a:off x="5583692" y="3853751"/>
+            <a:ext cx="720069" cy="369332"/>
+          </a:xfrm>
+          <a:prstGeom prst="rect">
+            <a:avLst/>
+          </a:prstGeom>
+          <a:noFill/>
+        </p:spPr>
+        <p:txBody>
+          <a:bodyPr wrap="none" rtlCol="0">
+            <a:spAutoFit/>
+          </a:bodyPr>
+          <a:lstStyle/>
+          <a:p>
+            <a:r>
+              <a:rPr lang="de-DE" dirty="0"/>
+              <a:t>JDBC</a:t>
+            </a:r>
+          </a:p>
+        </p:txBody>
+      </p:sp>
+      <p:sp>
+        <p:nvSpPr>
+          <p:cNvPr id="14" name="Flussdiagramm: Magnetplattenspeicher 13">
+            <a:extLst>
+              <a:ext uri="{FF2B5EF4-FFF2-40B4-BE49-F238E27FC236}">
+                <a16:creationId xmlns:a16="http://schemas.microsoft.com/office/drawing/2014/main" id="{71EDC17B-7B70-6BCA-7F9D-07F55F7EEDDD}"/>
+              </a:ext>
+            </a:extLst>
+          </p:cNvPr>
+          <p:cNvSpPr/>
+          <p:nvPr/>
+        </p:nvSpPr>
+        <p:spPr>
+          <a:xfrm>
+            <a:off x="7376160" y="2061371"/>
+            <a:ext cx="3421380" cy="4583709"/>
+          </a:xfrm>
+          <a:prstGeom prst="flowChartMagneticDisk">
+            <a:avLst/>
+          </a:prstGeom>
+        </p:spPr>
+        <p:style>
+          <a:lnRef idx="2">
+            <a:schemeClr val="accent1">
+              <a:shade val="15000"/>
+            </a:schemeClr>
+          </a:lnRef>
+          <a:fillRef idx="1">
+            <a:schemeClr val="accent1"/>
+          </a:fillRef>
+          <a:effectRef idx="0">
+            <a:schemeClr val="accent1"/>
+          </a:effectRef>
+          <a:fontRef idx="minor">
+            <a:schemeClr val="lt1"/>
+          </a:fontRef>
+        </p:style>
+        <p:txBody>
+          <a:bodyPr rtlCol="0" anchor="ctr"/>
+          <a:lstStyle/>
+          <a:p>
+            <a:pPr algn="ctr"/>
+            <a:endParaRPr lang="de-DE"/>
+          </a:p>
+        </p:txBody>
+      </p:sp>
+      <p:sp>
+        <p:nvSpPr>
+          <p:cNvPr id="22" name="Textfeld 21">
+            <a:extLst>
+              <a:ext uri="{FF2B5EF4-FFF2-40B4-BE49-F238E27FC236}">
+                <a16:creationId xmlns:a16="http://schemas.microsoft.com/office/drawing/2014/main" id="{8ADD7C2C-765C-79DA-7F9B-D779BAA6C795}"/>
+              </a:ext>
+            </a:extLst>
+          </p:cNvPr>
+          <p:cNvSpPr txBox="1"/>
+          <p:nvPr/>
+        </p:nvSpPr>
+        <p:spPr>
+          <a:xfrm>
+            <a:off x="7772400" y="2355959"/>
+            <a:ext cx="2362200" cy="954107"/>
+          </a:xfrm>
+          <a:prstGeom prst="rect">
+            <a:avLst/>
+          </a:prstGeom>
+          <a:noFill/>
+        </p:spPr>
+        <p:txBody>
+          <a:bodyPr wrap="square" rtlCol="0">
+            <a:spAutoFit/>
+          </a:bodyPr>
+          <a:lstStyle/>
+          <a:p>
+            <a:pPr algn="ctr"/>
+            <a:r>
+              <a:rPr lang="de-DE" sz="2800" dirty="0">
+                <a:solidFill>
+                  <a:schemeClr val="bg1"/>
+                </a:solidFill>
+              </a:rPr>
+              <a:t>MySQL</a:t>
+            </a:r>
+          </a:p>
+          <a:p>
+            <a:pPr algn="ctr"/>
+            <a:r>
+              <a:rPr lang="de-DE" sz="2800" dirty="0">
+                <a:solidFill>
+                  <a:schemeClr val="bg1"/>
+                </a:solidFill>
+              </a:rPr>
+              <a:t>Datenbank</a:t>
+            </a:r>
+          </a:p>
+        </p:txBody>
+      </p:sp>
+      <p:sp>
+        <p:nvSpPr>
+          <p:cNvPr id="26" name="Rechteck 25">
+            <a:extLst>
+              <a:ext uri="{FF2B5EF4-FFF2-40B4-BE49-F238E27FC236}">
+                <a16:creationId xmlns:a16="http://schemas.microsoft.com/office/drawing/2014/main" id="{4D3DA021-4323-8D2C-C58F-1BD5D3E9DDFC}"/>
+              </a:ext>
+            </a:extLst>
+          </p:cNvPr>
+          <p:cNvSpPr/>
+          <p:nvPr/>
+        </p:nvSpPr>
+        <p:spPr>
+          <a:xfrm>
+            <a:off x="1209924" y="2152811"/>
+            <a:ext cx="1693681" cy="636109"/>
+          </a:xfrm>
+          <a:prstGeom prst="rect">
+            <a:avLst/>
+          </a:prstGeom>
+        </p:spPr>
+        <p:style>
+          <a:lnRef idx="2">
+            <a:schemeClr val="accent1">
+              <a:shade val="15000"/>
+            </a:schemeClr>
+          </a:lnRef>
+          <a:fillRef idx="1">
+            <a:schemeClr val="accent1"/>
+          </a:fillRef>
+          <a:effectRef idx="0">
+            <a:schemeClr val="accent1"/>
+          </a:effectRef>
+          <a:fontRef idx="minor">
+            <a:schemeClr val="lt1"/>
+          </a:fontRef>
+        </p:style>
+        <p:txBody>
+          <a:bodyPr rtlCol="0" anchor="ctr"/>
+          <a:lstStyle/>
+          <a:p>
+            <a:pPr algn="ctr"/>
+            <a:r>
+              <a:rPr lang="de-DE" dirty="0"/>
+              <a:t>Username / </a:t>
+            </a:r>
+            <a:br>
+              <a:rPr lang="de-DE" dirty="0"/>
+            </a:br>
+            <a:r>
+              <a:rPr lang="de-DE" dirty="0"/>
+              <a:t>accountName</a:t>
+            </a:r>
+          </a:p>
+        </p:txBody>
+      </p:sp>
+      <p:cxnSp>
+        <p:nvCxnSpPr>
+          <p:cNvPr id="29" name="Verbinder: gewinkelt 28">
+            <a:extLst>
+              <a:ext uri="{FF2B5EF4-FFF2-40B4-BE49-F238E27FC236}">
+                <a16:creationId xmlns:a16="http://schemas.microsoft.com/office/drawing/2014/main" id="{85A640F8-4D05-1792-BCE8-48BD3130FB2A}"/>
+              </a:ext>
+            </a:extLst>
+          </p:cNvPr>
+          <p:cNvCxnSpPr>
+            <a:cxnSpLocks/>
+            <a:stCxn id="26" idx="3"/>
+            <a:endCxn id="25" idx="3"/>
+          </p:cNvCxnSpPr>
+          <p:nvPr/>
+        </p:nvCxnSpPr>
+        <p:spPr>
+          <a:xfrm>
+            <a:off x="2903605" y="2470866"/>
+            <a:ext cx="1782695" cy="1775959"/>
+          </a:xfrm>
+          <a:prstGeom prst="bentConnector3">
+            <a:avLst>
+              <a:gd name="adj1" fmla="val 46997"/>
+            </a:avLst>
+          </a:prstGeom>
+          <a:ln w="57150">
+            <a:headEnd type="none" w="med" len="med"/>
+            <a:tailEnd type="none" w="med" len="med"/>
+          </a:ln>
+        </p:spPr>
+        <p:style>
+          <a:lnRef idx="2">
+            <a:schemeClr val="accent6"/>
+          </a:lnRef>
+          <a:fillRef idx="0">
+            <a:schemeClr val="accent6"/>
+          </a:fillRef>
+          <a:effectRef idx="1">
+            <a:schemeClr val="accent6"/>
+          </a:effectRef>
+          <a:fontRef idx="minor">
+            <a:schemeClr val="tx1"/>
+          </a:fontRef>
+        </p:style>
+      </p:cxnSp>
+      <p:cxnSp>
+        <p:nvCxnSpPr>
+          <p:cNvPr id="41" name="Verbinder: gewinkelt 40">
+            <a:extLst>
+              <a:ext uri="{FF2B5EF4-FFF2-40B4-BE49-F238E27FC236}">
+                <a16:creationId xmlns:a16="http://schemas.microsoft.com/office/drawing/2014/main" id="{E0ECE4DD-FADD-B5F5-391B-973FE936E7FA}"/>
+              </a:ext>
+            </a:extLst>
+          </p:cNvPr>
+          <p:cNvCxnSpPr>
+            <a:cxnSpLocks/>
+            <a:endCxn id="25" idx="3"/>
+          </p:cNvCxnSpPr>
+          <p:nvPr/>
+        </p:nvCxnSpPr>
+        <p:spPr>
+          <a:xfrm flipV="1">
+            <a:off x="3131820" y="4246825"/>
+            <a:ext cx="1554480" cy="476110"/>
+          </a:xfrm>
+          <a:prstGeom prst="bentConnector3">
+            <a:avLst>
+              <a:gd name="adj1" fmla="val 39216"/>
+            </a:avLst>
+          </a:prstGeom>
+          <a:ln w="57150">
+            <a:headEnd type="none" w="med" len="med"/>
+            <a:tailEnd type="none" w="med" len="med"/>
+          </a:ln>
+        </p:spPr>
+        <p:style>
+          <a:lnRef idx="2">
+            <a:schemeClr val="accent6"/>
+          </a:lnRef>
+          <a:fillRef idx="0">
+            <a:schemeClr val="accent6"/>
+          </a:fillRef>
+          <a:effectRef idx="1">
+            <a:schemeClr val="accent6"/>
+          </a:effectRef>
+          <a:fontRef idx="minor">
+            <a:schemeClr val="tx1"/>
+          </a:fontRef>
+        </p:style>
+      </p:cxnSp>
+      <p:pic>
+        <p:nvPicPr>
+          <p:cNvPr id="49" name="Grafik 48">
+            <a:extLst>
+              <a:ext uri="{FF2B5EF4-FFF2-40B4-BE49-F238E27FC236}">
+                <a16:creationId xmlns:a16="http://schemas.microsoft.com/office/drawing/2014/main" id="{164D5E9D-96AB-9A05-469E-B17A18E031CB}"/>
+              </a:ext>
+            </a:extLst>
+          </p:cNvPr>
+          <p:cNvPicPr>
+            <a:picLocks noChangeAspect="1"/>
+          </p:cNvPicPr>
+          <p:nvPr/>
+        </p:nvPicPr>
+        <p:blipFill>
+          <a:blip r:embed="rId2"/>
+          <a:stretch>
+            <a:fillRect/>
+          </a:stretch>
+        </p:blipFill>
+        <p:spPr>
+          <a:xfrm>
+            <a:off x="7642859" y="3760805"/>
+            <a:ext cx="2877773" cy="1712625"/>
+          </a:xfrm>
+          <a:prstGeom prst="rect">
+            <a:avLst/>
+          </a:prstGeom>
+        </p:spPr>
+      </p:pic>
+    </p:spTree>
+    <p:extLst>
+      <p:ext uri="{BB962C8B-B14F-4D97-AF65-F5344CB8AC3E}">
+        <p14:creationId xmlns:p14="http://schemas.microsoft.com/office/powerpoint/2010/main" val="2673720107"/>
+      </p:ext>
+    </p:extLst>
+  </p:cSld>
+  <p:clrMapOvr>
+    <a:masterClrMapping/>
+  </p:clrMapOvr>
+</p:sld>
+</file>
+
+<file path=ppt/slides/slide11.xml><?xml version="1.0" encoding="utf-8"?>
+<p:sld xmlns:a="http://schemas.openxmlformats.org/drawingml/2006/main" xmlns:r="http://schemas.openxmlformats.org/officeDocument/2006/relationships" xmlns:p="http://schemas.openxmlformats.org/presentationml/2006/main">
+  <p:cSld>
+    <p:spTree>
+      <p:nvGrpSpPr>
+        <p:cNvPr id="1" name="">
+          <a:extLst>
+            <a:ext uri="{FF2B5EF4-FFF2-40B4-BE49-F238E27FC236}">
+              <a16:creationId xmlns:a16="http://schemas.microsoft.com/office/drawing/2014/main" id="{ACE2E954-15E9-E447-34AD-12C92502B7ED}"/>
+            </a:ext>
+          </a:extLst>
+        </p:cNvPr>
+        <p:cNvGrpSpPr/>
+        <p:nvPr/>
+      </p:nvGrpSpPr>
+      <p:grpSpPr>
+        <a:xfrm>
+          <a:off x="0" y="0"/>
+          <a:ext cx="0" cy="0"/>
+          <a:chOff x="0" y="0"/>
+          <a:chExt cx="0" cy="0"/>
+        </a:xfrm>
+      </p:grpSpPr>
+      <p:sp>
+        <p:nvSpPr>
+          <p:cNvPr id="2" name="Titel 1">
+            <a:extLst>
+              <a:ext uri="{FF2B5EF4-FFF2-40B4-BE49-F238E27FC236}">
+                <a16:creationId xmlns:a16="http://schemas.microsoft.com/office/drawing/2014/main" id="{8FC10906-ACDD-7AFE-8BA3-325E4297E194}"/>
+              </a:ext>
+            </a:extLst>
+          </p:cNvPr>
+          <p:cNvSpPr>
+            <a:spLocks noGrp="1"/>
+          </p:cNvSpPr>
+          <p:nvPr>
+            <p:ph type="title"/>
+          </p:nvPr>
+        </p:nvSpPr>
+        <p:spPr/>
+        <p:txBody>
+          <a:bodyPr/>
+          <a:lstStyle/>
+          <a:p>
+            <a:r>
+              <a:rPr lang="de-DE" b="1" dirty="0">
+                <a:effectLst>
+                  <a:outerShdw blurRad="38100" dist="38100" dir="2700000" algn="tl">
+                    <a:srgbClr val="000000">
+                      <a:alpha val="43137"/>
+                    </a:srgbClr>
+                  </a:outerShdw>
+                </a:effectLst>
+              </a:rPr>
+              <a:t>Umsetzung </a:t>
+            </a:r>
+            <a:r>
+              <a:rPr lang="de-DE" dirty="0">
+                <a:effectLst>
+                  <a:outerShdw blurRad="38100" dist="38100" dir="2700000" algn="tl">
+                    <a:srgbClr val="000000">
+                      <a:alpha val="43137"/>
+                    </a:srgbClr>
+                  </a:outerShdw>
+                </a:effectLst>
+              </a:rPr>
+              <a:t>- Probleme</a:t>
+            </a:r>
+            <a:endParaRPr lang="de-DE" b="1" dirty="0">
+              <a:effectLst>
+                <a:outerShdw blurRad="38100" dist="38100" dir="2700000" algn="tl">
+                  <a:srgbClr val="000000">
+                    <a:alpha val="43137"/>
+                  </a:srgbClr>
+                </a:outerShdw>
+              </a:effectLst>
+            </a:endParaRPr>
+          </a:p>
+        </p:txBody>
+      </p:sp>
+      <p:sp>
+        <p:nvSpPr>
+          <p:cNvPr id="3" name="Inhaltsplatzhalter 2">
+            <a:extLst>
+              <a:ext uri="{FF2B5EF4-FFF2-40B4-BE49-F238E27FC236}">
+                <a16:creationId xmlns:a16="http://schemas.microsoft.com/office/drawing/2014/main" id="{56BFDCF3-FFA4-1EA1-D381-2110A1905742}"/>
+              </a:ext>
+            </a:extLst>
+          </p:cNvPr>
+          <p:cNvSpPr>
+            <a:spLocks noGrp="1"/>
+          </p:cNvSpPr>
+          <p:nvPr>
+            <p:ph idx="1"/>
+          </p:nvPr>
+        </p:nvSpPr>
+        <p:spPr/>
+        <p:txBody>
+          <a:bodyPr>
+            <a:normAutofit/>
+          </a:bodyPr>
+          <a:lstStyle/>
+          <a:p>
+            <a:r>
+              <a:rPr lang="de-DE" sz="2000" dirty="0"/>
+              <a:t>Implementierung von Buttons (Bearbeiten, Kopieren, Anzeigen) in eine JTable</a:t>
+            </a:r>
+          </a:p>
+        </p:txBody>
+      </p:sp>
+    </p:spTree>
+    <p:extLst>
+      <p:ext uri="{BB962C8B-B14F-4D97-AF65-F5344CB8AC3E}">
+        <p14:creationId xmlns:p14="http://schemas.microsoft.com/office/powerpoint/2010/main" val="3903202141"/>
+      </p:ext>
+    </p:extLst>
+  </p:cSld>
+  <p:clrMapOvr>
+    <a:masterClrMapping/>
+  </p:clrMapOvr>
+</p:sld>
+</file>
+
+<file path=ppt/slides/slide12.xml><?xml version="1.0" encoding="utf-8"?>
+<p:sld xmlns:a="http://schemas.openxmlformats.org/drawingml/2006/main" xmlns:r="http://schemas.openxmlformats.org/officeDocument/2006/relationships" xmlns:p="http://schemas.openxmlformats.org/presentationml/2006/main">
+  <p:cSld>
+    <p:spTree>
+      <p:nvGrpSpPr>
         <p:cNvPr id="1" name=""/>
         <p:cNvGrpSpPr/>
         <p:nvPr/>
@@ -4725,7 +5556,7 @@
           <a:p>
             <a:r>
               <a:rPr lang="de-DE" sz="2000" dirty="0"/>
-              <a:t>AES-256 (für Verschlüsselung der Passwörter)</a:t>
+              <a:t>AES-256-GCM (für Verschlüsselung der Passwörter)</a:t>
             </a:r>
           </a:p>
           <a:p>
@@ -6689,7 +7520,7 @@
         <p:cNvPr id="1" name="">
           <a:extLst>
             <a:ext uri="{FF2B5EF4-FFF2-40B4-BE49-F238E27FC236}">
-              <a16:creationId xmlns:a16="http://schemas.microsoft.com/office/drawing/2014/main" id="{D47F335A-FDF6-4F22-13CA-08ED29DA569C}"/>
+              <a16:creationId xmlns:a16="http://schemas.microsoft.com/office/drawing/2014/main" id="{5254532F-50B0-3C8E-A519-894B989F50BA}"/>
             </a:ext>
           </a:extLst>
         </p:cNvPr>
@@ -6709,7 +7540,7 @@
           <p:cNvPr id="2" name="Titel 1">
             <a:extLst>
               <a:ext uri="{FF2B5EF4-FFF2-40B4-BE49-F238E27FC236}">
-                <a16:creationId xmlns:a16="http://schemas.microsoft.com/office/drawing/2014/main" id="{6C3531C2-260F-3E4A-71D3-613883B29F3F}"/>
+                <a16:creationId xmlns:a16="http://schemas.microsoft.com/office/drawing/2014/main" id="{6705FA3B-82EF-9F9C-6B48-7B00C9A567CC}"/>
               </a:ext>
             </a:extLst>
           </p:cNvPr>
@@ -6747,122 +7578,7 @@
                   </a:outerShdw>
                 </a:effectLst>
               </a:rPr>
-              <a:t> - Verschlüsselung</a:t>
-            </a:r>
-          </a:p>
-        </p:txBody>
-      </p:sp>
-      <p:sp>
-        <p:nvSpPr>
-          <p:cNvPr id="3" name="Inhaltsplatzhalter 2">
-            <a:extLst>
-              <a:ext uri="{FF2B5EF4-FFF2-40B4-BE49-F238E27FC236}">
-                <a16:creationId xmlns:a16="http://schemas.microsoft.com/office/drawing/2014/main" id="{68F71C22-1CEE-7C61-96C3-081EEC5F2B92}"/>
-              </a:ext>
-            </a:extLst>
-          </p:cNvPr>
-          <p:cNvSpPr>
-            <a:spLocks noGrp="1"/>
-          </p:cNvSpPr>
-          <p:nvPr>
-            <p:ph idx="1"/>
-          </p:nvPr>
-        </p:nvSpPr>
-        <p:spPr/>
-        <p:txBody>
-          <a:bodyPr>
-            <a:normAutofit/>
-          </a:bodyPr>
-          <a:lstStyle/>
-          <a:p>
-            <a:r>
-              <a:rPr lang="de-DE" sz="2000" b="1" dirty="0"/>
-              <a:t>Allgemein:</a:t>
-            </a:r>
-            <a:endParaRPr lang="de-DE" sz="2400" b="1" dirty="0"/>
-          </a:p>
-        </p:txBody>
-      </p:sp>
-    </p:spTree>
-    <p:extLst>
-      <p:ext uri="{BB962C8B-B14F-4D97-AF65-F5344CB8AC3E}">
-        <p14:creationId xmlns:p14="http://schemas.microsoft.com/office/powerpoint/2010/main" val="2950061998"/>
-      </p:ext>
-    </p:extLst>
-  </p:cSld>
-  <p:clrMapOvr>
-    <a:masterClrMapping/>
-  </p:clrMapOvr>
-</p:sld>
-</file>
-
-<file path=ppt/slides/slide8.xml><?xml version="1.0" encoding="utf-8"?>
-<p:sld xmlns:a="http://schemas.openxmlformats.org/drawingml/2006/main" xmlns:r="http://schemas.openxmlformats.org/officeDocument/2006/relationships" xmlns:p="http://schemas.openxmlformats.org/presentationml/2006/main">
-  <p:cSld>
-    <p:spTree>
-      <p:nvGrpSpPr>
-        <p:cNvPr id="1" name="">
-          <a:extLst>
-            <a:ext uri="{FF2B5EF4-FFF2-40B4-BE49-F238E27FC236}">
-              <a16:creationId xmlns:a16="http://schemas.microsoft.com/office/drawing/2014/main" id="{64007FDD-F578-96F3-717C-B2F13D303536}"/>
-            </a:ext>
-          </a:extLst>
-        </p:cNvPr>
-        <p:cNvGrpSpPr/>
-        <p:nvPr/>
-      </p:nvGrpSpPr>
-      <p:grpSpPr>
-        <a:xfrm>
-          <a:off x="0" y="0"/>
-          <a:ext cx="0" cy="0"/>
-          <a:chOff x="0" y="0"/>
-          <a:chExt cx="0" cy="0"/>
-        </a:xfrm>
-      </p:grpSpPr>
-      <p:sp>
-        <p:nvSpPr>
-          <p:cNvPr id="2" name="Titel 1">
-            <a:extLst>
-              <a:ext uri="{FF2B5EF4-FFF2-40B4-BE49-F238E27FC236}">
-                <a16:creationId xmlns:a16="http://schemas.microsoft.com/office/drawing/2014/main" id="{2A3703A7-369E-1A90-7ABC-1FDCE42AF615}"/>
-              </a:ext>
-            </a:extLst>
-          </p:cNvPr>
-          <p:cNvSpPr>
-            <a:spLocks noGrp="1"/>
-          </p:cNvSpPr>
-          <p:nvPr>
-            <p:ph type="title"/>
-          </p:nvPr>
-        </p:nvSpPr>
-        <p:spPr/>
-        <p:txBody>
-          <a:bodyPr/>
-          <a:lstStyle/>
-          <a:p>
-            <a:r>
-              <a:rPr lang="de-DE" b="1" dirty="0">
-                <a:effectLst>
-                  <a:outerShdw blurRad="38100" dist="38100" dir="2700000" algn="tl">
-                    <a:srgbClr val="000000">
-                      <a:alpha val="43137"/>
-                    </a:srgbClr>
-                  </a:outerShdw>
-                </a:effectLst>
-              </a:rPr>
-              <a:t>Umsetzung</a:t>
-            </a:r>
-            <a:r>
-              <a:rPr lang="de-DE" dirty="0">
-                <a:effectLst>
-                  <a:outerShdw blurRad="38100" dist="38100" dir="2700000" algn="tl">
-                    <a:srgbClr val="000000">
-                      <a:alpha val="43137"/>
-                    </a:srgbClr>
-                  </a:outerShdw>
-                </a:effectLst>
-              </a:rPr>
-              <a:t> - Speicherung der Passwörter</a:t>
+              <a:t> - Speicherung der Passwörter (Lokal)</a:t>
             </a:r>
             <a:endParaRPr lang="de-DE" u="sng" dirty="0">
               <a:effectLst>
@@ -6881,7 +7597,7 @@
           <p:cNvPr id="3" name="Inhaltsplatzhalter 2">
             <a:extLst>
               <a:ext uri="{FF2B5EF4-FFF2-40B4-BE49-F238E27FC236}">
-                <a16:creationId xmlns:a16="http://schemas.microsoft.com/office/drawing/2014/main" id="{99E85B5E-D0BE-DD00-27B5-D23F7A822FFA}"/>
+                <a16:creationId xmlns:a16="http://schemas.microsoft.com/office/drawing/2014/main" id="{FAD2D4F3-D0CC-8FEE-A212-B4DF45B6B9C9}"/>
               </a:ext>
             </a:extLst>
           </p:cNvPr>
@@ -6906,7 +7622,7 @@
             <a:pPr lvl="1"/>
             <a:r>
               <a:rPr lang="de-DE" sz="1600" b="1" dirty="0"/>
-              <a:t>Passwörter werden als Binär Datei abgespeichert</a:t>
+              <a:t>Passwörter werden als eine Binär Datei pro Benutzer abgespeichert</a:t>
             </a:r>
           </a:p>
           <a:p>
@@ -6937,7 +7653,7 @@
           <p:cNvPr id="31" name="Grafik 30" descr="Ein Bild, das Text, Screenshot, Schrift, Software enthält.&#10;&#10;KI-generierte Inhalte können fehlerhaft sein.">
             <a:extLst>
               <a:ext uri="{FF2B5EF4-FFF2-40B4-BE49-F238E27FC236}">
-                <a16:creationId xmlns:a16="http://schemas.microsoft.com/office/drawing/2014/main" id="{0CF0FEA1-D368-CF83-65CD-110854CC019E}"/>
+                <a16:creationId xmlns:a16="http://schemas.microsoft.com/office/drawing/2014/main" id="{71C76BD5-5211-E302-7C5D-DE550874CBFD}"/>
               </a:ext>
             </a:extLst>
           </p:cNvPr>
@@ -6973,7 +7689,7 @@
           <p:cNvPr id="35" name="Grafik 34" descr="Ein Bild, das Text, Screenshot, Software, Schrift enthält.&#10;&#10;KI-generierte Inhalte können fehlerhaft sein.">
             <a:extLst>
               <a:ext uri="{FF2B5EF4-FFF2-40B4-BE49-F238E27FC236}">
-                <a16:creationId xmlns:a16="http://schemas.microsoft.com/office/drawing/2014/main" id="{CC675AC4-1CA5-8CA7-1015-F47AF164203F}"/>
+                <a16:creationId xmlns:a16="http://schemas.microsoft.com/office/drawing/2014/main" id="{F6D92926-AF1B-A23B-975F-1FAED6904655}"/>
               </a:ext>
             </a:extLst>
           </p:cNvPr>
@@ -7009,7 +7725,7 @@
           <p:cNvPr id="33" name="Grafik 32" descr="Ein Bild, das Text, Screenshot, Software, Schrift enthält.&#10;&#10;KI-generierte Inhalte können fehlerhaft sein.">
             <a:extLst>
               <a:ext uri="{FF2B5EF4-FFF2-40B4-BE49-F238E27FC236}">
-                <a16:creationId xmlns:a16="http://schemas.microsoft.com/office/drawing/2014/main" id="{A8E14C6D-8DEF-1B4D-E2D9-27A6C0763465}"/>
+                <a16:creationId xmlns:a16="http://schemas.microsoft.com/office/drawing/2014/main" id="{BB48BBA6-685D-4364-5EF0-C6044D63E5D7}"/>
               </a:ext>
             </a:extLst>
           </p:cNvPr>
@@ -7045,7 +7761,7 @@
           <p:cNvPr id="37" name="Grafik 36" descr="Ein Bild, das Text, Screenshot, Software, Computersymbol enthält.&#10;&#10;KI-generierte Inhalte können fehlerhaft sein.">
             <a:extLst>
               <a:ext uri="{FF2B5EF4-FFF2-40B4-BE49-F238E27FC236}">
-                <a16:creationId xmlns:a16="http://schemas.microsoft.com/office/drawing/2014/main" id="{19336577-A2A4-1B24-6AD6-73E48FE8A3D5}"/>
+                <a16:creationId xmlns:a16="http://schemas.microsoft.com/office/drawing/2014/main" id="{90766113-DCFE-67B2-BE8F-C622B6D9ABB6}"/>
               </a:ext>
             </a:extLst>
           </p:cNvPr>
@@ -7079,7 +7795,7 @@
     </p:spTree>
     <p:extLst>
       <p:ext uri="{BB962C8B-B14F-4D97-AF65-F5344CB8AC3E}">
-        <p14:creationId xmlns:p14="http://schemas.microsoft.com/office/powerpoint/2010/main" val="2673720107"/>
+        <p14:creationId xmlns:p14="http://schemas.microsoft.com/office/powerpoint/2010/main" val="2043039090"/>
       </p:ext>
     </p:extLst>
   </p:cSld>
@@ -7347,7 +8063,7 @@
 </p:sld>
 </file>
 
-<file path=ppt/slides/slide9.xml><?xml version="1.0" encoding="utf-8"?>
+<file path=ppt/slides/slide8.xml><?xml version="1.0" encoding="utf-8"?>
 <p:sld xmlns:a="http://schemas.openxmlformats.org/drawingml/2006/main" xmlns:r="http://schemas.openxmlformats.org/officeDocument/2006/relationships" xmlns:p="http://schemas.openxmlformats.org/presentationml/2006/main">
   <p:cSld>
     <p:spTree>
@@ -7355,7 +8071,7 @@
         <p:cNvPr id="1" name="">
           <a:extLst>
             <a:ext uri="{FF2B5EF4-FFF2-40B4-BE49-F238E27FC236}">
-              <a16:creationId xmlns:a16="http://schemas.microsoft.com/office/drawing/2014/main" id="{ACE2E954-15E9-E447-34AD-12C92502B7ED}"/>
+              <a16:creationId xmlns:a16="http://schemas.microsoft.com/office/drawing/2014/main" id="{D47F335A-FDF6-4F22-13CA-08ED29DA569C}"/>
             </a:ext>
           </a:extLst>
         </p:cNvPr>
@@ -7372,10 +8088,154 @@
       </p:grpSpPr>
       <p:sp>
         <p:nvSpPr>
+          <p:cNvPr id="43" name="Rechteck 42">
+            <a:extLst>
+              <a:ext uri="{FF2B5EF4-FFF2-40B4-BE49-F238E27FC236}">
+                <a16:creationId xmlns:a16="http://schemas.microsoft.com/office/drawing/2014/main" id="{55442D66-9D20-BED2-65CE-AF06167F338A}"/>
+              </a:ext>
+            </a:extLst>
+          </p:cNvPr>
+          <p:cNvSpPr/>
+          <p:nvPr/>
+        </p:nvSpPr>
+        <p:spPr>
+          <a:xfrm>
+            <a:off x="9448803" y="3345180"/>
+            <a:ext cx="2080258" cy="3147694"/>
+          </a:xfrm>
+          <a:prstGeom prst="rect">
+            <a:avLst/>
+          </a:prstGeom>
+        </p:spPr>
+        <p:style>
+          <a:lnRef idx="2">
+            <a:schemeClr val="accent4">
+              <a:shade val="15000"/>
+            </a:schemeClr>
+          </a:lnRef>
+          <a:fillRef idx="1">
+            <a:schemeClr val="accent4"/>
+          </a:fillRef>
+          <a:effectRef idx="0">
+            <a:schemeClr val="accent4"/>
+          </a:effectRef>
+          <a:fontRef idx="minor">
+            <a:schemeClr val="lt1"/>
+          </a:fontRef>
+        </p:style>
+        <p:txBody>
+          <a:bodyPr rtlCol="0" anchor="t"/>
+          <a:lstStyle/>
+          <a:p>
+            <a:r>
+              <a:rPr lang="de-DE" dirty="0"/>
+              <a:t>Hauptfenster</a:t>
+            </a:r>
+          </a:p>
+        </p:txBody>
+      </p:sp>
+      <p:sp>
+        <p:nvSpPr>
+          <p:cNvPr id="14" name="Rechteck 13">
+            <a:extLst>
+              <a:ext uri="{FF2B5EF4-FFF2-40B4-BE49-F238E27FC236}">
+                <a16:creationId xmlns:a16="http://schemas.microsoft.com/office/drawing/2014/main" id="{C6E42FAA-740A-F474-5731-C146C9DE1E1E}"/>
+              </a:ext>
+            </a:extLst>
+          </p:cNvPr>
+          <p:cNvSpPr/>
+          <p:nvPr/>
+        </p:nvSpPr>
+        <p:spPr>
+          <a:xfrm>
+            <a:off x="4838700" y="1531621"/>
+            <a:ext cx="4419600" cy="1293020"/>
+          </a:xfrm>
+          <a:prstGeom prst="rect">
+            <a:avLst/>
+          </a:prstGeom>
+        </p:spPr>
+        <p:style>
+          <a:lnRef idx="2">
+            <a:schemeClr val="accent4">
+              <a:shade val="15000"/>
+            </a:schemeClr>
+          </a:lnRef>
+          <a:fillRef idx="1">
+            <a:schemeClr val="accent4"/>
+          </a:fillRef>
+          <a:effectRef idx="0">
+            <a:schemeClr val="accent4"/>
+          </a:effectRef>
+          <a:fontRef idx="minor">
+            <a:schemeClr val="lt1"/>
+          </a:fontRef>
+        </p:style>
+        <p:txBody>
+          <a:bodyPr rtlCol="0" anchor="t"/>
+          <a:lstStyle/>
+          <a:p>
+            <a:r>
+              <a:rPr lang="de-DE" dirty="0"/>
+              <a:t>Anmelde Maske</a:t>
+            </a:r>
+          </a:p>
+        </p:txBody>
+      </p:sp>
+      <p:sp>
+        <p:nvSpPr>
+          <p:cNvPr id="13" name="Rechteck 12">
+            <a:extLst>
+              <a:ext uri="{FF2B5EF4-FFF2-40B4-BE49-F238E27FC236}">
+                <a16:creationId xmlns:a16="http://schemas.microsoft.com/office/drawing/2014/main" id="{4B11FFC5-91C5-0BA4-1BD8-6BAA5617AF0F}"/>
+              </a:ext>
+            </a:extLst>
+          </p:cNvPr>
+          <p:cNvSpPr/>
+          <p:nvPr/>
+        </p:nvSpPr>
+        <p:spPr>
+          <a:xfrm>
+            <a:off x="844550" y="1992791"/>
+            <a:ext cx="2622550" cy="4706459"/>
+          </a:xfrm>
+          <a:prstGeom prst="rect">
+            <a:avLst/>
+          </a:prstGeom>
+        </p:spPr>
+        <p:style>
+          <a:lnRef idx="2">
+            <a:schemeClr val="accent4">
+              <a:shade val="15000"/>
+            </a:schemeClr>
+          </a:lnRef>
+          <a:fillRef idx="1">
+            <a:schemeClr val="accent4"/>
+          </a:fillRef>
+          <a:effectRef idx="0">
+            <a:schemeClr val="accent4"/>
+          </a:effectRef>
+          <a:fontRef idx="minor">
+            <a:schemeClr val="lt1"/>
+          </a:fontRef>
+        </p:style>
+        <p:txBody>
+          <a:bodyPr rtlCol="0" anchor="t"/>
+          <a:lstStyle/>
+          <a:p>
+            <a:r>
+              <a:rPr lang="de-DE" dirty="0"/>
+              <a:t>Datei</a:t>
+            </a:r>
+          </a:p>
+        </p:txBody>
+      </p:sp>
+      <p:sp>
+        <p:nvSpPr>
           <p:cNvPr id="2" name="Titel 1">
             <a:extLst>
               <a:ext uri="{FF2B5EF4-FFF2-40B4-BE49-F238E27FC236}">
-                <a16:creationId xmlns:a16="http://schemas.microsoft.com/office/drawing/2014/main" id="{8FC10906-ACDD-7AFE-8BA3-325E4297E194}"/>
+                <a16:creationId xmlns:a16="http://schemas.microsoft.com/office/drawing/2014/main" id="{6C3531C2-260F-3E4A-71D3-613883B29F3F}"/>
               </a:ext>
             </a:extLst>
           </p:cNvPr>
@@ -7401,7 +8261,7 @@
                   </a:outerShdw>
                 </a:effectLst>
               </a:rPr>
-              <a:t>Umsetzung </a:t>
+              <a:t>Umsetzung</a:t>
             </a:r>
             <a:r>
               <a:rPr lang="de-DE" dirty="0">
@@ -7413,26 +8273,1288 @@
                   </a:outerShdw>
                 </a:effectLst>
               </a:rPr>
-              <a:t>- Probleme</a:t>
-            </a:r>
-            <a:endParaRPr lang="de-DE" b="1" dirty="0">
-              <a:effectLst>
-                <a:outerShdw blurRad="38100" dist="38100" dir="2700000" algn="tl">
-                  <a:srgbClr val="000000">
-                    <a:alpha val="43137"/>
-                  </a:srgbClr>
-                </a:outerShdw>
-              </a:effectLst>
-            </a:endParaRPr>
-          </a:p>
-        </p:txBody>
-      </p:sp>
-      <p:sp>
-        <p:nvSpPr>
-          <p:cNvPr id="3" name="Inhaltsplatzhalter 2">
-            <a:extLst>
-              <a:ext uri="{FF2B5EF4-FFF2-40B4-BE49-F238E27FC236}">
-                <a16:creationId xmlns:a16="http://schemas.microsoft.com/office/drawing/2014/main" id="{56BFDCF3-FFA4-1EA1-D381-2110A1905742}"/>
+              <a:t> - Verschlüsselung</a:t>
+            </a:r>
+          </a:p>
+        </p:txBody>
+      </p:sp>
+      <p:sp>
+        <p:nvSpPr>
+          <p:cNvPr id="4" name="Rechteck 3">
+            <a:extLst>
+              <a:ext uri="{FF2B5EF4-FFF2-40B4-BE49-F238E27FC236}">
+                <a16:creationId xmlns:a16="http://schemas.microsoft.com/office/drawing/2014/main" id="{6A4FFCB1-7B71-2568-52FD-19DDB9FDCD2F}"/>
+              </a:ext>
+            </a:extLst>
+          </p:cNvPr>
+          <p:cNvSpPr/>
+          <p:nvPr/>
+        </p:nvSpPr>
+        <p:spPr>
+          <a:xfrm>
+            <a:off x="4373562" y="4052888"/>
+            <a:ext cx="4624388" cy="1166811"/>
+          </a:xfrm>
+          <a:custGeom>
+            <a:avLst/>
+            <a:gdLst>
+              <a:gd name="connsiteX0" fmla="*/ 0 w 4622800"/>
+              <a:gd name="connsiteY0" fmla="*/ 0 h 1166811"/>
+              <a:gd name="connsiteX1" fmla="*/ 4622800 w 4622800"/>
+              <a:gd name="connsiteY1" fmla="*/ 0 h 1166811"/>
+              <a:gd name="connsiteX2" fmla="*/ 4622800 w 4622800"/>
+              <a:gd name="connsiteY2" fmla="*/ 1166811 h 1166811"/>
+              <a:gd name="connsiteX3" fmla="*/ 0 w 4622800"/>
+              <a:gd name="connsiteY3" fmla="*/ 1166811 h 1166811"/>
+              <a:gd name="connsiteX4" fmla="*/ 0 w 4622800"/>
+              <a:gd name="connsiteY4" fmla="*/ 0 h 1166811"/>
+              <a:gd name="connsiteX0" fmla="*/ 6350 w 4629150"/>
+              <a:gd name="connsiteY0" fmla="*/ 0 h 1166811"/>
+              <a:gd name="connsiteX1" fmla="*/ 4629150 w 4629150"/>
+              <a:gd name="connsiteY1" fmla="*/ 0 h 1166811"/>
+              <a:gd name="connsiteX2" fmla="*/ 4629150 w 4629150"/>
+              <a:gd name="connsiteY2" fmla="*/ 1166811 h 1166811"/>
+              <a:gd name="connsiteX3" fmla="*/ 6350 w 4629150"/>
+              <a:gd name="connsiteY3" fmla="*/ 1166811 h 1166811"/>
+              <a:gd name="connsiteX4" fmla="*/ 0 w 4629150"/>
+              <a:gd name="connsiteY4" fmla="*/ 931862 h 1166811"/>
+              <a:gd name="connsiteX5" fmla="*/ 6350 w 4629150"/>
+              <a:gd name="connsiteY5" fmla="*/ 0 h 1166811"/>
+              <a:gd name="connsiteX0" fmla="*/ 6350 w 4629150"/>
+              <a:gd name="connsiteY0" fmla="*/ 0 h 1166811"/>
+              <a:gd name="connsiteX1" fmla="*/ 4629150 w 4629150"/>
+              <a:gd name="connsiteY1" fmla="*/ 0 h 1166811"/>
+              <a:gd name="connsiteX2" fmla="*/ 4629150 w 4629150"/>
+              <a:gd name="connsiteY2" fmla="*/ 1166811 h 1166811"/>
+              <a:gd name="connsiteX3" fmla="*/ 6350 w 4629150"/>
+              <a:gd name="connsiteY3" fmla="*/ 1166811 h 1166811"/>
+              <a:gd name="connsiteX4" fmla="*/ 0 w 4629150"/>
+              <a:gd name="connsiteY4" fmla="*/ 341312 h 1166811"/>
+              <a:gd name="connsiteX5" fmla="*/ 6350 w 4629150"/>
+              <a:gd name="connsiteY5" fmla="*/ 0 h 1166811"/>
+              <a:gd name="connsiteX0" fmla="*/ 1588 w 4624388"/>
+              <a:gd name="connsiteY0" fmla="*/ 0 h 1166811"/>
+              <a:gd name="connsiteX1" fmla="*/ 4624388 w 4624388"/>
+              <a:gd name="connsiteY1" fmla="*/ 0 h 1166811"/>
+              <a:gd name="connsiteX2" fmla="*/ 4624388 w 4624388"/>
+              <a:gd name="connsiteY2" fmla="*/ 1166811 h 1166811"/>
+              <a:gd name="connsiteX3" fmla="*/ 1588 w 4624388"/>
+              <a:gd name="connsiteY3" fmla="*/ 1166811 h 1166811"/>
+              <a:gd name="connsiteX4" fmla="*/ 0 w 4624388"/>
+              <a:gd name="connsiteY4" fmla="*/ 341312 h 1166811"/>
+              <a:gd name="connsiteX5" fmla="*/ 1588 w 4624388"/>
+              <a:gd name="connsiteY5" fmla="*/ 0 h 1166811"/>
+            </a:gdLst>
+            <a:ahLst/>
+            <a:cxnLst>
+              <a:cxn ang="0">
+                <a:pos x="connsiteX0" y="connsiteY0"/>
+              </a:cxn>
+              <a:cxn ang="0">
+                <a:pos x="connsiteX1" y="connsiteY1"/>
+              </a:cxn>
+              <a:cxn ang="0">
+                <a:pos x="connsiteX2" y="connsiteY2"/>
+              </a:cxn>
+              <a:cxn ang="0">
+                <a:pos x="connsiteX3" y="connsiteY3"/>
+              </a:cxn>
+              <a:cxn ang="0">
+                <a:pos x="connsiteX4" y="connsiteY4"/>
+              </a:cxn>
+              <a:cxn ang="0">
+                <a:pos x="connsiteX5" y="connsiteY5"/>
+              </a:cxn>
+            </a:cxnLst>
+            <a:rect l="l" t="t" r="r" b="b"/>
+            <a:pathLst>
+              <a:path w="4624388" h="1166811">
+                <a:moveTo>
+                  <a:pt x="1588" y="0"/>
+                </a:moveTo>
+                <a:lnTo>
+                  <a:pt x="4624388" y="0"/>
+                </a:lnTo>
+                <a:lnTo>
+                  <a:pt x="4624388" y="1166811"/>
+                </a:lnTo>
+                <a:lnTo>
+                  <a:pt x="1588" y="1166811"/>
+                </a:lnTo>
+                <a:cubicBezTo>
+                  <a:pt x="-529" y="891645"/>
+                  <a:pt x="2117" y="616478"/>
+                  <a:pt x="0" y="341312"/>
+                </a:cubicBezTo>
+                <a:cubicBezTo>
+                  <a:pt x="2117" y="30691"/>
+                  <a:pt x="-529" y="310621"/>
+                  <a:pt x="1588" y="0"/>
+                </a:cubicBezTo>
+                <a:close/>
+              </a:path>
+            </a:pathLst>
+          </a:custGeom>
+        </p:spPr>
+        <p:style>
+          <a:lnRef idx="2">
+            <a:schemeClr val="accent1">
+              <a:shade val="15000"/>
+            </a:schemeClr>
+          </a:lnRef>
+          <a:fillRef idx="1">
+            <a:schemeClr val="accent1"/>
+          </a:fillRef>
+          <a:effectRef idx="0">
+            <a:schemeClr val="accent1"/>
+          </a:effectRef>
+          <a:fontRef idx="minor">
+            <a:schemeClr val="lt1"/>
+          </a:fontRef>
+        </p:style>
+        <p:txBody>
+          <a:bodyPr rtlCol="0" anchor="ctr"/>
+          <a:lstStyle/>
+          <a:p>
+            <a:pPr algn="ctr"/>
+            <a:r>
+              <a:rPr lang="de-DE" dirty="0"/>
+              <a:t>Verschlüsselung mittels</a:t>
+            </a:r>
+          </a:p>
+          <a:p>
+            <a:pPr algn="ctr"/>
+            <a:r>
+              <a:rPr lang="de-DE" dirty="0"/>
+              <a:t>AES256-GCM</a:t>
+            </a:r>
+          </a:p>
+        </p:txBody>
+      </p:sp>
+      <p:sp>
+        <p:nvSpPr>
+          <p:cNvPr id="5" name="Rechteck 4">
+            <a:extLst>
+              <a:ext uri="{FF2B5EF4-FFF2-40B4-BE49-F238E27FC236}">
+                <a16:creationId xmlns:a16="http://schemas.microsoft.com/office/drawing/2014/main" id="{5B5B6B37-D552-6555-AA15-7D01359DDAAD}"/>
+              </a:ext>
+            </a:extLst>
+          </p:cNvPr>
+          <p:cNvSpPr/>
+          <p:nvPr/>
+        </p:nvSpPr>
+        <p:spPr>
+          <a:xfrm>
+            <a:off x="1200150" y="2501900"/>
+            <a:ext cx="1803400" cy="438150"/>
+          </a:xfrm>
+          <a:prstGeom prst="rect">
+            <a:avLst/>
+          </a:prstGeom>
+        </p:spPr>
+        <p:style>
+          <a:lnRef idx="2">
+            <a:schemeClr val="accent1">
+              <a:shade val="15000"/>
+            </a:schemeClr>
+          </a:lnRef>
+          <a:fillRef idx="1">
+            <a:schemeClr val="accent1"/>
+          </a:fillRef>
+          <a:effectRef idx="0">
+            <a:schemeClr val="accent1"/>
+          </a:effectRef>
+          <a:fontRef idx="minor">
+            <a:schemeClr val="lt1"/>
+          </a:fontRef>
+        </p:style>
+        <p:txBody>
+          <a:bodyPr rtlCol="0" anchor="ctr"/>
+          <a:lstStyle/>
+          <a:p>
+            <a:pPr algn="ctr"/>
+            <a:r>
+              <a:rPr lang="de-DE" dirty="0"/>
+              <a:t>Salt</a:t>
+            </a:r>
+          </a:p>
+        </p:txBody>
+      </p:sp>
+      <p:sp>
+        <p:nvSpPr>
+          <p:cNvPr id="6" name="Rechteck 5">
+            <a:extLst>
+              <a:ext uri="{FF2B5EF4-FFF2-40B4-BE49-F238E27FC236}">
+                <a16:creationId xmlns:a16="http://schemas.microsoft.com/office/drawing/2014/main" id="{CB22EE3A-4E53-C6A4-9036-0FDC4596957B}"/>
+              </a:ext>
+            </a:extLst>
+          </p:cNvPr>
+          <p:cNvSpPr/>
+          <p:nvPr/>
+        </p:nvSpPr>
+        <p:spPr>
+          <a:xfrm>
+            <a:off x="1200150" y="3061494"/>
+            <a:ext cx="1803400" cy="438150"/>
+          </a:xfrm>
+          <a:prstGeom prst="rect">
+            <a:avLst/>
+          </a:prstGeom>
+        </p:spPr>
+        <p:style>
+          <a:lnRef idx="2">
+            <a:schemeClr val="accent1">
+              <a:shade val="15000"/>
+            </a:schemeClr>
+          </a:lnRef>
+          <a:fillRef idx="1">
+            <a:schemeClr val="accent1"/>
+          </a:fillRef>
+          <a:effectRef idx="0">
+            <a:schemeClr val="accent1"/>
+          </a:effectRef>
+          <a:fontRef idx="minor">
+            <a:schemeClr val="lt1"/>
+          </a:fontRef>
+        </p:style>
+        <p:txBody>
+          <a:bodyPr rtlCol="0" anchor="ctr"/>
+          <a:lstStyle/>
+          <a:p>
+            <a:pPr algn="ctr"/>
+            <a:r>
+              <a:rPr lang="de-DE" dirty="0"/>
+              <a:t>IV</a:t>
+            </a:r>
+          </a:p>
+        </p:txBody>
+      </p:sp>
+      <p:sp>
+        <p:nvSpPr>
+          <p:cNvPr id="7" name="Rechteck 6">
+            <a:extLst>
+              <a:ext uri="{FF2B5EF4-FFF2-40B4-BE49-F238E27FC236}">
+                <a16:creationId xmlns:a16="http://schemas.microsoft.com/office/drawing/2014/main" id="{14210BBF-EEA9-6490-B445-193CBD322B55}"/>
+              </a:ext>
+            </a:extLst>
+          </p:cNvPr>
+          <p:cNvSpPr/>
+          <p:nvPr/>
+        </p:nvSpPr>
+        <p:spPr>
+          <a:xfrm>
+            <a:off x="1200150" y="3618706"/>
+            <a:ext cx="1803400" cy="2909093"/>
+          </a:xfrm>
+          <a:prstGeom prst="rect">
+            <a:avLst/>
+          </a:prstGeom>
+        </p:spPr>
+        <p:style>
+          <a:lnRef idx="2">
+            <a:schemeClr val="accent1">
+              <a:shade val="15000"/>
+            </a:schemeClr>
+          </a:lnRef>
+          <a:fillRef idx="1">
+            <a:schemeClr val="accent1"/>
+          </a:fillRef>
+          <a:effectRef idx="0">
+            <a:schemeClr val="accent1"/>
+          </a:effectRef>
+          <a:fontRef idx="minor">
+            <a:schemeClr val="lt1"/>
+          </a:fontRef>
+        </p:style>
+        <p:txBody>
+          <a:bodyPr rtlCol="0" anchor="ctr"/>
+          <a:lstStyle/>
+          <a:p>
+            <a:pPr algn="ctr"/>
+            <a:r>
+              <a:rPr lang="de-DE" dirty="0"/>
+              <a:t>Verschlüsselte</a:t>
+            </a:r>
+          </a:p>
+          <a:p>
+            <a:pPr algn="ctr"/>
+            <a:r>
+              <a:rPr lang="de-DE" dirty="0"/>
+              <a:t>Daten</a:t>
+            </a:r>
+          </a:p>
+        </p:txBody>
+      </p:sp>
+      <p:sp>
+        <p:nvSpPr>
+          <p:cNvPr id="8" name="Rechteck 7">
+            <a:extLst>
+              <a:ext uri="{FF2B5EF4-FFF2-40B4-BE49-F238E27FC236}">
+                <a16:creationId xmlns:a16="http://schemas.microsoft.com/office/drawing/2014/main" id="{9B83E9CE-2092-21E9-3B48-06142B90B997}"/>
+              </a:ext>
+            </a:extLst>
+          </p:cNvPr>
+          <p:cNvSpPr/>
+          <p:nvPr/>
+        </p:nvSpPr>
+        <p:spPr>
+          <a:xfrm>
+            <a:off x="7239000" y="2003901"/>
+            <a:ext cx="1758950" cy="671512"/>
+          </a:xfrm>
+          <a:prstGeom prst="rect">
+            <a:avLst/>
+          </a:prstGeom>
+        </p:spPr>
+        <p:style>
+          <a:lnRef idx="2">
+            <a:schemeClr val="accent1">
+              <a:shade val="15000"/>
+            </a:schemeClr>
+          </a:lnRef>
+          <a:fillRef idx="1">
+            <a:schemeClr val="accent1"/>
+          </a:fillRef>
+          <a:effectRef idx="0">
+            <a:schemeClr val="accent1"/>
+          </a:effectRef>
+          <a:fontRef idx="minor">
+            <a:schemeClr val="lt1"/>
+          </a:fontRef>
+        </p:style>
+        <p:txBody>
+          <a:bodyPr rtlCol="0" anchor="ctr"/>
+          <a:lstStyle/>
+          <a:p>
+            <a:pPr algn="ctr"/>
+            <a:r>
+              <a:rPr lang="de-DE" dirty="0"/>
+              <a:t>Master</a:t>
+            </a:r>
+          </a:p>
+          <a:p>
+            <a:pPr algn="ctr"/>
+            <a:r>
+              <a:rPr lang="de-DE" dirty="0"/>
+              <a:t>Passwort</a:t>
+            </a:r>
+          </a:p>
+        </p:txBody>
+      </p:sp>
+      <p:sp>
+        <p:nvSpPr>
+          <p:cNvPr id="9" name="Rechteck 8">
+            <a:extLst>
+              <a:ext uri="{FF2B5EF4-FFF2-40B4-BE49-F238E27FC236}">
+                <a16:creationId xmlns:a16="http://schemas.microsoft.com/office/drawing/2014/main" id="{FED52332-0F5E-4EE6-0EE9-46F8A824BF04}"/>
+              </a:ext>
+            </a:extLst>
+          </p:cNvPr>
+          <p:cNvSpPr/>
+          <p:nvPr/>
+        </p:nvSpPr>
+        <p:spPr>
+          <a:xfrm>
+            <a:off x="5791200" y="3066257"/>
+            <a:ext cx="3206750" cy="673100"/>
+          </a:xfrm>
+          <a:prstGeom prst="rect">
+            <a:avLst/>
+          </a:prstGeom>
+        </p:spPr>
+        <p:style>
+          <a:lnRef idx="2">
+            <a:schemeClr val="accent1">
+              <a:shade val="15000"/>
+            </a:schemeClr>
+          </a:lnRef>
+          <a:fillRef idx="1">
+            <a:schemeClr val="accent1"/>
+          </a:fillRef>
+          <a:effectRef idx="0">
+            <a:schemeClr val="accent1"/>
+          </a:effectRef>
+          <a:fontRef idx="minor">
+            <a:schemeClr val="lt1"/>
+          </a:fontRef>
+        </p:style>
+        <p:txBody>
+          <a:bodyPr rtlCol="0" anchor="ctr"/>
+          <a:lstStyle/>
+          <a:p>
+            <a:pPr algn="ctr"/>
+            <a:r>
+              <a:rPr lang="de-DE" dirty="0"/>
+              <a:t>Key Ableitung mittels</a:t>
+            </a:r>
+          </a:p>
+          <a:p>
+            <a:pPr algn="ctr"/>
+            <a:r>
+              <a:rPr lang="de-DE" dirty="0"/>
+              <a:t>PBKDF2-HMAC-SHA256</a:t>
+            </a:r>
+          </a:p>
+        </p:txBody>
+      </p:sp>
+      <p:sp>
+        <p:nvSpPr>
+          <p:cNvPr id="12" name="Rechteck 11">
+            <a:extLst>
+              <a:ext uri="{FF2B5EF4-FFF2-40B4-BE49-F238E27FC236}">
+                <a16:creationId xmlns:a16="http://schemas.microsoft.com/office/drawing/2014/main" id="{BEDC6B56-3A3C-58F9-2397-24E63B04E08D}"/>
+              </a:ext>
+            </a:extLst>
+          </p:cNvPr>
+          <p:cNvSpPr/>
+          <p:nvPr/>
+        </p:nvSpPr>
+        <p:spPr>
+          <a:xfrm>
+            <a:off x="9969500" y="4052888"/>
+            <a:ext cx="1111250" cy="2124075"/>
+          </a:xfrm>
+          <a:prstGeom prst="rect">
+            <a:avLst/>
+          </a:prstGeom>
+        </p:spPr>
+        <p:style>
+          <a:lnRef idx="2">
+            <a:schemeClr val="accent1">
+              <a:shade val="15000"/>
+            </a:schemeClr>
+          </a:lnRef>
+          <a:fillRef idx="1">
+            <a:schemeClr val="accent1"/>
+          </a:fillRef>
+          <a:effectRef idx="0">
+            <a:schemeClr val="accent1"/>
+          </a:effectRef>
+          <a:fontRef idx="minor">
+            <a:schemeClr val="lt1"/>
+          </a:fontRef>
+        </p:style>
+        <p:txBody>
+          <a:bodyPr rtlCol="0" anchor="ctr"/>
+          <a:lstStyle/>
+          <a:p>
+            <a:pPr algn="ctr"/>
+            <a:r>
+              <a:rPr lang="de-DE" dirty="0"/>
+              <a:t>Klartext</a:t>
+            </a:r>
+          </a:p>
+          <a:p>
+            <a:pPr algn="ctr"/>
+            <a:r>
+              <a:rPr lang="de-DE" dirty="0"/>
+              <a:t>Daten</a:t>
+            </a:r>
+          </a:p>
+        </p:txBody>
+      </p:sp>
+      <p:cxnSp>
+        <p:nvCxnSpPr>
+          <p:cNvPr id="16" name="Verbinder: gewinkelt 15">
+            <a:extLst>
+              <a:ext uri="{FF2B5EF4-FFF2-40B4-BE49-F238E27FC236}">
+                <a16:creationId xmlns:a16="http://schemas.microsoft.com/office/drawing/2014/main" id="{2F36659F-4F1B-5679-40DC-E2568ED209DF}"/>
+              </a:ext>
+            </a:extLst>
+          </p:cNvPr>
+          <p:cNvCxnSpPr>
+            <a:cxnSpLocks/>
+            <a:stCxn id="5" idx="3"/>
+          </p:cNvCxnSpPr>
+          <p:nvPr/>
+        </p:nvCxnSpPr>
+        <p:spPr>
+          <a:xfrm>
+            <a:off x="3003550" y="2720975"/>
+            <a:ext cx="1182688" cy="506414"/>
+          </a:xfrm>
+          <a:prstGeom prst="bentConnector3">
+            <a:avLst>
+              <a:gd name="adj1" fmla="val 61597"/>
+            </a:avLst>
+          </a:prstGeom>
+          <a:ln w="57150">
+            <a:solidFill>
+              <a:srgbClr val="FF0000"/>
+            </a:solidFill>
+            <a:headEnd type="triangle" w="med" len="med"/>
+            <a:tailEnd type="none" w="med" len="med"/>
+          </a:ln>
+        </p:spPr>
+        <p:style>
+          <a:lnRef idx="2">
+            <a:schemeClr val="accent6"/>
+          </a:lnRef>
+          <a:fillRef idx="0">
+            <a:schemeClr val="accent6"/>
+          </a:fillRef>
+          <a:effectRef idx="1">
+            <a:schemeClr val="accent6"/>
+          </a:effectRef>
+          <a:fontRef idx="minor">
+            <a:schemeClr val="tx1"/>
+          </a:fontRef>
+        </p:style>
+      </p:cxnSp>
+      <p:cxnSp>
+        <p:nvCxnSpPr>
+          <p:cNvPr id="29" name="Verbinder: gewinkelt 28">
+            <a:extLst>
+              <a:ext uri="{FF2B5EF4-FFF2-40B4-BE49-F238E27FC236}">
+                <a16:creationId xmlns:a16="http://schemas.microsoft.com/office/drawing/2014/main" id="{26082CC4-49B8-8B7F-8EE6-50D815B71D2D}"/>
+              </a:ext>
+            </a:extLst>
+          </p:cNvPr>
+          <p:cNvCxnSpPr>
+            <a:cxnSpLocks/>
+            <a:stCxn id="6" idx="3"/>
+            <a:endCxn id="56" idx="1"/>
+          </p:cNvCxnSpPr>
+          <p:nvPr/>
+        </p:nvCxnSpPr>
+        <p:spPr>
+          <a:xfrm>
+            <a:off x="3003550" y="3280569"/>
+            <a:ext cx="1177929" cy="117475"/>
+          </a:xfrm>
+          <a:prstGeom prst="bentConnector3">
+            <a:avLst/>
+          </a:prstGeom>
+          <a:ln w="57150">
+            <a:solidFill>
+              <a:srgbClr val="FF0000"/>
+            </a:solidFill>
+            <a:headEnd type="triangle" w="med" len="med"/>
+            <a:tailEnd type="none" w="med" len="med"/>
+          </a:ln>
+        </p:spPr>
+        <p:style>
+          <a:lnRef idx="2">
+            <a:schemeClr val="accent6"/>
+          </a:lnRef>
+          <a:fillRef idx="0">
+            <a:schemeClr val="accent6"/>
+          </a:fillRef>
+          <a:effectRef idx="1">
+            <a:schemeClr val="accent6"/>
+          </a:effectRef>
+          <a:fontRef idx="minor">
+            <a:schemeClr val="tx1"/>
+          </a:fontRef>
+        </p:style>
+      </p:cxnSp>
+      <p:cxnSp>
+        <p:nvCxnSpPr>
+          <p:cNvPr id="31" name="Verbinder: gewinkelt 30">
+            <a:extLst>
+              <a:ext uri="{FF2B5EF4-FFF2-40B4-BE49-F238E27FC236}">
+                <a16:creationId xmlns:a16="http://schemas.microsoft.com/office/drawing/2014/main" id="{6E27F0B3-0E02-675C-E99F-2D807275383A}"/>
+              </a:ext>
+            </a:extLst>
+          </p:cNvPr>
+          <p:cNvCxnSpPr>
+            <a:cxnSpLocks/>
+            <a:stCxn id="7" idx="3"/>
+          </p:cNvCxnSpPr>
+          <p:nvPr/>
+        </p:nvCxnSpPr>
+        <p:spPr>
+          <a:xfrm flipV="1">
+            <a:off x="3003550" y="4855368"/>
+            <a:ext cx="1365250" cy="217885"/>
+          </a:xfrm>
+          <a:prstGeom prst="bentConnector3">
+            <a:avLst/>
+          </a:prstGeom>
+          <a:ln w="57150">
+            <a:headEnd type="triangle" w="med" len="med"/>
+            <a:tailEnd type="none" w="med" len="med"/>
+          </a:ln>
+        </p:spPr>
+        <p:style>
+          <a:lnRef idx="2">
+            <a:schemeClr val="accent6"/>
+          </a:lnRef>
+          <a:fillRef idx="0">
+            <a:schemeClr val="accent6"/>
+          </a:fillRef>
+          <a:effectRef idx="1">
+            <a:schemeClr val="accent6"/>
+          </a:effectRef>
+          <a:fontRef idx="minor">
+            <a:schemeClr val="tx1"/>
+          </a:fontRef>
+        </p:style>
+      </p:cxnSp>
+      <p:cxnSp>
+        <p:nvCxnSpPr>
+          <p:cNvPr id="38" name="Gerade Verbindung mit Pfeil 37">
+            <a:extLst>
+              <a:ext uri="{FF2B5EF4-FFF2-40B4-BE49-F238E27FC236}">
+                <a16:creationId xmlns:a16="http://schemas.microsoft.com/office/drawing/2014/main" id="{744C0A11-B705-C721-D27D-DA7719E39C20}"/>
+              </a:ext>
+            </a:extLst>
+          </p:cNvPr>
+          <p:cNvCxnSpPr>
+            <a:cxnSpLocks/>
+            <a:stCxn id="8" idx="2"/>
+          </p:cNvCxnSpPr>
+          <p:nvPr/>
+        </p:nvCxnSpPr>
+        <p:spPr>
+          <a:xfrm>
+            <a:off x="8118475" y="2675413"/>
+            <a:ext cx="0" cy="386081"/>
+          </a:xfrm>
+          <a:prstGeom prst="straightConnector1">
+            <a:avLst/>
+          </a:prstGeom>
+          <a:ln w="57150">
+            <a:tailEnd type="triangle"/>
+          </a:ln>
+        </p:spPr>
+        <p:style>
+          <a:lnRef idx="2">
+            <a:schemeClr val="accent6"/>
+          </a:lnRef>
+          <a:fillRef idx="0">
+            <a:schemeClr val="accent6"/>
+          </a:fillRef>
+          <a:effectRef idx="1">
+            <a:schemeClr val="accent6"/>
+          </a:effectRef>
+          <a:fontRef idx="minor">
+            <a:schemeClr val="tx1"/>
+          </a:fontRef>
+        </p:style>
+      </p:cxnSp>
+      <p:cxnSp>
+        <p:nvCxnSpPr>
+          <p:cNvPr id="40" name="Gerade Verbindung mit Pfeil 39">
+            <a:extLst>
+              <a:ext uri="{FF2B5EF4-FFF2-40B4-BE49-F238E27FC236}">
+                <a16:creationId xmlns:a16="http://schemas.microsoft.com/office/drawing/2014/main" id="{2A7D50FC-0369-A4A9-5474-818F88DFED03}"/>
+              </a:ext>
+            </a:extLst>
+          </p:cNvPr>
+          <p:cNvCxnSpPr>
+            <a:stCxn id="9" idx="2"/>
+          </p:cNvCxnSpPr>
+          <p:nvPr/>
+        </p:nvCxnSpPr>
+        <p:spPr>
+          <a:xfrm>
+            <a:off x="7394575" y="3739357"/>
+            <a:ext cx="0" cy="313531"/>
+          </a:xfrm>
+          <a:prstGeom prst="straightConnector1">
+            <a:avLst/>
+          </a:prstGeom>
+          <a:ln w="57150">
+            <a:tailEnd type="triangle"/>
+          </a:ln>
+        </p:spPr>
+        <p:style>
+          <a:lnRef idx="2">
+            <a:schemeClr val="accent6"/>
+          </a:lnRef>
+          <a:fillRef idx="0">
+            <a:schemeClr val="accent6"/>
+          </a:fillRef>
+          <a:effectRef idx="1">
+            <a:schemeClr val="accent6"/>
+          </a:effectRef>
+          <a:fontRef idx="minor">
+            <a:schemeClr val="tx1"/>
+          </a:fontRef>
+        </p:style>
+      </p:cxnSp>
+      <p:cxnSp>
+        <p:nvCxnSpPr>
+          <p:cNvPr id="42" name="Gerade Verbindung mit Pfeil 41">
+            <a:extLst>
+              <a:ext uri="{FF2B5EF4-FFF2-40B4-BE49-F238E27FC236}">
+                <a16:creationId xmlns:a16="http://schemas.microsoft.com/office/drawing/2014/main" id="{DE5B91FB-EAFB-D760-0DF8-7694B2F84516}"/>
+              </a:ext>
+            </a:extLst>
+          </p:cNvPr>
+          <p:cNvCxnSpPr/>
+          <p:nvPr/>
+        </p:nvCxnSpPr>
+        <p:spPr>
+          <a:xfrm>
+            <a:off x="8997950" y="4636293"/>
+            <a:ext cx="971550" cy="0"/>
+          </a:xfrm>
+          <a:prstGeom prst="straightConnector1">
+            <a:avLst/>
+          </a:prstGeom>
+          <a:ln w="57150">
+            <a:headEnd type="triangle" w="med" len="med"/>
+            <a:tailEnd type="none" w="med" len="med"/>
+          </a:ln>
+        </p:spPr>
+        <p:style>
+          <a:lnRef idx="2">
+            <a:schemeClr val="accent6"/>
+          </a:lnRef>
+          <a:fillRef idx="0">
+            <a:schemeClr val="accent6"/>
+          </a:fillRef>
+          <a:effectRef idx="1">
+            <a:schemeClr val="accent6"/>
+          </a:effectRef>
+          <a:fontRef idx="minor">
+            <a:schemeClr val="tx1"/>
+          </a:fontRef>
+        </p:style>
+      </p:cxnSp>
+      <p:sp>
+        <p:nvSpPr>
+          <p:cNvPr id="49" name="Rechteck 48">
+            <a:extLst>
+              <a:ext uri="{FF2B5EF4-FFF2-40B4-BE49-F238E27FC236}">
+                <a16:creationId xmlns:a16="http://schemas.microsoft.com/office/drawing/2014/main" id="{F525E0AF-05BA-4D6E-2752-F2FF14AEECC7}"/>
+              </a:ext>
+            </a:extLst>
+          </p:cNvPr>
+          <p:cNvSpPr/>
+          <p:nvPr/>
+        </p:nvSpPr>
+        <p:spPr>
+          <a:xfrm>
+            <a:off x="5219700" y="1992791"/>
+            <a:ext cx="1758950" cy="671512"/>
+          </a:xfrm>
+          <a:prstGeom prst="rect">
+            <a:avLst/>
+          </a:prstGeom>
+        </p:spPr>
+        <p:style>
+          <a:lnRef idx="2">
+            <a:schemeClr val="accent1">
+              <a:shade val="15000"/>
+            </a:schemeClr>
+          </a:lnRef>
+          <a:fillRef idx="1">
+            <a:schemeClr val="accent1"/>
+          </a:fillRef>
+          <a:effectRef idx="0">
+            <a:schemeClr val="accent1"/>
+          </a:effectRef>
+          <a:fontRef idx="minor">
+            <a:schemeClr val="lt1"/>
+          </a:fontRef>
+        </p:style>
+        <p:txBody>
+          <a:bodyPr rtlCol="0" anchor="ctr"/>
+          <a:lstStyle/>
+          <a:p>
+            <a:pPr algn="ctr"/>
+            <a:r>
+              <a:rPr lang="de-DE" dirty="0"/>
+              <a:t>Username</a:t>
+            </a:r>
+          </a:p>
+        </p:txBody>
+      </p:sp>
+      <p:cxnSp>
+        <p:nvCxnSpPr>
+          <p:cNvPr id="51" name="Gerade Verbindung mit Pfeil 50">
+            <a:extLst>
+              <a:ext uri="{FF2B5EF4-FFF2-40B4-BE49-F238E27FC236}">
+                <a16:creationId xmlns:a16="http://schemas.microsoft.com/office/drawing/2014/main" id="{E0094C3E-561E-1E15-E56C-83A4A9724F4F}"/>
+              </a:ext>
+            </a:extLst>
+          </p:cNvPr>
+          <p:cNvCxnSpPr>
+            <a:stCxn id="49" idx="1"/>
+          </p:cNvCxnSpPr>
+          <p:nvPr/>
+        </p:nvCxnSpPr>
+        <p:spPr>
+          <a:xfrm flipH="1">
+            <a:off x="3467100" y="2328547"/>
+            <a:ext cx="1752600" cy="11110"/>
+          </a:xfrm>
+          <a:prstGeom prst="straightConnector1">
+            <a:avLst/>
+          </a:prstGeom>
+          <a:ln w="57150">
+            <a:tailEnd type="triangle"/>
+          </a:ln>
+        </p:spPr>
+        <p:style>
+          <a:lnRef idx="2">
+            <a:schemeClr val="accent6"/>
+          </a:lnRef>
+          <a:fillRef idx="0">
+            <a:schemeClr val="accent6"/>
+          </a:fillRef>
+          <a:effectRef idx="1">
+            <a:schemeClr val="accent6"/>
+          </a:effectRef>
+          <a:fontRef idx="minor">
+            <a:schemeClr val="tx1"/>
+          </a:fontRef>
+        </p:style>
+      </p:cxnSp>
+      <p:sp>
+        <p:nvSpPr>
+          <p:cNvPr id="52" name="Textfeld 51">
+            <a:extLst>
+              <a:ext uri="{FF2B5EF4-FFF2-40B4-BE49-F238E27FC236}">
+                <a16:creationId xmlns:a16="http://schemas.microsoft.com/office/drawing/2014/main" id="{4FEADF0C-8A4A-FB74-E91A-29514645F116}"/>
+              </a:ext>
+            </a:extLst>
+          </p:cNvPr>
+          <p:cNvSpPr txBox="1"/>
+          <p:nvPr/>
+        </p:nvSpPr>
+        <p:spPr>
+          <a:xfrm>
+            <a:off x="3658569" y="1796515"/>
+            <a:ext cx="1180131" cy="523220"/>
+          </a:xfrm>
+          <a:prstGeom prst="rect">
+            <a:avLst/>
+          </a:prstGeom>
+          <a:noFill/>
+        </p:spPr>
+        <p:txBody>
+          <a:bodyPr wrap="none" rtlCol="0">
+            <a:spAutoFit/>
+          </a:bodyPr>
+          <a:lstStyle/>
+          <a:p>
+            <a:pPr algn="ctr"/>
+            <a:r>
+              <a:rPr lang="de-DE" sz="1400" dirty="0"/>
+              <a:t>Generierung </a:t>
+            </a:r>
+          </a:p>
+          <a:p>
+            <a:pPr algn="ctr"/>
+            <a:r>
+              <a:rPr lang="de-DE" sz="1400" dirty="0"/>
+              <a:t>Datei</a:t>
+            </a:r>
+          </a:p>
+        </p:txBody>
+      </p:sp>
+      <p:sp>
+        <p:nvSpPr>
+          <p:cNvPr id="56" name="Rechteck 55">
+            <a:extLst>
+              <a:ext uri="{FF2B5EF4-FFF2-40B4-BE49-F238E27FC236}">
+                <a16:creationId xmlns:a16="http://schemas.microsoft.com/office/drawing/2014/main" id="{0D16D9BC-85B3-2266-047B-5166E862DEBA}"/>
+              </a:ext>
+            </a:extLst>
+          </p:cNvPr>
+          <p:cNvSpPr/>
+          <p:nvPr/>
+        </p:nvSpPr>
+        <p:spPr>
+          <a:xfrm>
+            <a:off x="4181479" y="3061494"/>
+            <a:ext cx="1335087" cy="673100"/>
+          </a:xfrm>
+          <a:prstGeom prst="rect">
+            <a:avLst/>
+          </a:prstGeom>
+        </p:spPr>
+        <p:style>
+          <a:lnRef idx="2">
+            <a:schemeClr val="accent1">
+              <a:shade val="15000"/>
+            </a:schemeClr>
+          </a:lnRef>
+          <a:fillRef idx="1">
+            <a:schemeClr val="accent1"/>
+          </a:fillRef>
+          <a:effectRef idx="0">
+            <a:schemeClr val="accent1"/>
+          </a:effectRef>
+          <a:fontRef idx="minor">
+            <a:schemeClr val="lt1"/>
+          </a:fontRef>
+        </p:style>
+        <p:txBody>
+          <a:bodyPr rtlCol="0" anchor="ctr"/>
+          <a:lstStyle/>
+          <a:p>
+            <a:pPr algn="ctr"/>
+            <a:r>
+              <a:rPr lang="de-DE" dirty="0"/>
+              <a:t>Generiere</a:t>
+            </a:r>
+          </a:p>
+          <a:p>
+            <a:pPr algn="ctr"/>
+            <a:r>
+              <a:rPr lang="de-DE" dirty="0"/>
+              <a:t>IV + Salt</a:t>
+            </a:r>
+          </a:p>
+        </p:txBody>
+      </p:sp>
+      <p:cxnSp>
+        <p:nvCxnSpPr>
+          <p:cNvPr id="61" name="Gerade Verbindung mit Pfeil 60">
+            <a:extLst>
+              <a:ext uri="{FF2B5EF4-FFF2-40B4-BE49-F238E27FC236}">
+                <a16:creationId xmlns:a16="http://schemas.microsoft.com/office/drawing/2014/main" id="{B5966B15-5481-24DC-73BB-0A04D53D6366}"/>
+              </a:ext>
+            </a:extLst>
+          </p:cNvPr>
+          <p:cNvCxnSpPr/>
+          <p:nvPr/>
+        </p:nvCxnSpPr>
+        <p:spPr>
+          <a:xfrm>
+            <a:off x="4579620" y="3751265"/>
+            <a:ext cx="0" cy="301623"/>
+          </a:xfrm>
+          <a:prstGeom prst="straightConnector1">
+            <a:avLst/>
+          </a:prstGeom>
+          <a:ln w="57150">
+            <a:tailEnd type="triangle"/>
+          </a:ln>
+        </p:spPr>
+        <p:style>
+          <a:lnRef idx="2">
+            <a:schemeClr val="accent6"/>
+          </a:lnRef>
+          <a:fillRef idx="0">
+            <a:schemeClr val="accent6"/>
+          </a:fillRef>
+          <a:effectRef idx="1">
+            <a:schemeClr val="accent6"/>
+          </a:effectRef>
+          <a:fontRef idx="minor">
+            <a:schemeClr val="tx1"/>
+          </a:fontRef>
+        </p:style>
+      </p:cxnSp>
+      <p:cxnSp>
+        <p:nvCxnSpPr>
+          <p:cNvPr id="63" name="Gerade Verbindung mit Pfeil 62">
+            <a:extLst>
+              <a:ext uri="{FF2B5EF4-FFF2-40B4-BE49-F238E27FC236}">
+                <a16:creationId xmlns:a16="http://schemas.microsoft.com/office/drawing/2014/main" id="{71D6C7FC-B508-0E39-D8F5-561DFED9FA6B}"/>
+              </a:ext>
+            </a:extLst>
+          </p:cNvPr>
+          <p:cNvCxnSpPr>
+            <a:cxnSpLocks/>
+          </p:cNvCxnSpPr>
+          <p:nvPr/>
+        </p:nvCxnSpPr>
+        <p:spPr>
+          <a:xfrm>
+            <a:off x="5516566" y="3550444"/>
+            <a:ext cx="274634" cy="4763"/>
+          </a:xfrm>
+          <a:prstGeom prst="straightConnector1">
+            <a:avLst/>
+          </a:prstGeom>
+          <a:ln w="57150">
+            <a:tailEnd type="triangle"/>
+          </a:ln>
+        </p:spPr>
+        <p:style>
+          <a:lnRef idx="2">
+            <a:schemeClr val="accent6"/>
+          </a:lnRef>
+          <a:fillRef idx="0">
+            <a:schemeClr val="accent6"/>
+          </a:fillRef>
+          <a:effectRef idx="1">
+            <a:schemeClr val="accent6"/>
+          </a:effectRef>
+          <a:fontRef idx="minor">
+            <a:schemeClr val="tx1"/>
+          </a:fontRef>
+        </p:style>
+      </p:cxnSp>
+      <p:sp>
+        <p:nvSpPr>
+          <p:cNvPr id="64" name="Textfeld 63">
+            <a:extLst>
+              <a:ext uri="{FF2B5EF4-FFF2-40B4-BE49-F238E27FC236}">
+                <a16:creationId xmlns:a16="http://schemas.microsoft.com/office/drawing/2014/main" id="{86388E3E-0F6E-7F4C-537E-C7FA18E4A972}"/>
+              </a:ext>
+            </a:extLst>
+          </p:cNvPr>
+          <p:cNvSpPr txBox="1"/>
+          <p:nvPr/>
+        </p:nvSpPr>
+        <p:spPr>
+          <a:xfrm>
+            <a:off x="3686175" y="2813214"/>
+            <a:ext cx="790601" cy="261610"/>
+          </a:xfrm>
+          <a:prstGeom prst="rect">
+            <a:avLst/>
+          </a:prstGeom>
+          <a:noFill/>
+        </p:spPr>
+        <p:txBody>
+          <a:bodyPr wrap="none" rtlCol="0">
+            <a:spAutoFit/>
+          </a:bodyPr>
+          <a:lstStyle/>
+          <a:p>
+            <a:pPr algn="ctr"/>
+            <a:r>
+              <a:rPr lang="de-DE" sz="1100" dirty="0">
+                <a:solidFill>
+                  <a:srgbClr val="FF0000"/>
+                </a:solidFill>
+              </a:rPr>
+              <a:t>speichern</a:t>
+            </a:r>
+          </a:p>
+        </p:txBody>
+      </p:sp>
+      <p:sp>
+        <p:nvSpPr>
+          <p:cNvPr id="66" name="Pfeil: nach links 65">
+            <a:extLst>
+              <a:ext uri="{FF2B5EF4-FFF2-40B4-BE49-F238E27FC236}">
+                <a16:creationId xmlns:a16="http://schemas.microsoft.com/office/drawing/2014/main" id="{BEE5362A-9925-4F43-C915-2512281AA4FB}"/>
+              </a:ext>
+            </a:extLst>
+          </p:cNvPr>
+          <p:cNvSpPr/>
+          <p:nvPr/>
+        </p:nvSpPr>
+        <p:spPr>
+          <a:xfrm>
+            <a:off x="4541520" y="5768340"/>
+            <a:ext cx="3576955" cy="759459"/>
+          </a:xfrm>
+          <a:prstGeom prst="leftArrow">
+            <a:avLst/>
+          </a:prstGeom>
+        </p:spPr>
+        <p:style>
+          <a:lnRef idx="2">
+            <a:schemeClr val="accent2">
+              <a:shade val="15000"/>
+            </a:schemeClr>
+          </a:lnRef>
+          <a:fillRef idx="1">
+            <a:schemeClr val="accent2"/>
+          </a:fillRef>
+          <a:effectRef idx="0">
+            <a:schemeClr val="accent2"/>
+          </a:effectRef>
+          <a:fontRef idx="minor">
+            <a:schemeClr val="lt1"/>
+          </a:fontRef>
+        </p:style>
+        <p:txBody>
+          <a:bodyPr rtlCol="0" anchor="ctr"/>
+          <a:lstStyle/>
+          <a:p>
+            <a:pPr algn="ctr"/>
+            <a:endParaRPr lang="de-DE"/>
+          </a:p>
+        </p:txBody>
+      </p:sp>
+    </p:spTree>
+    <p:extLst>
+      <p:ext uri="{BB962C8B-B14F-4D97-AF65-F5344CB8AC3E}">
+        <p14:creationId xmlns:p14="http://schemas.microsoft.com/office/powerpoint/2010/main" val="2950061998"/>
+      </p:ext>
+    </p:extLst>
+  </p:cSld>
+  <p:clrMapOvr>
+    <a:masterClrMapping/>
+  </p:clrMapOvr>
+</p:sld>
+</file>
+
+<file path=ppt/slides/slide9.xml><?xml version="1.0" encoding="utf-8"?>
+<p:sld xmlns:a="http://schemas.openxmlformats.org/drawingml/2006/main" xmlns:r="http://schemas.openxmlformats.org/officeDocument/2006/relationships" xmlns:p="http://schemas.openxmlformats.org/presentationml/2006/main">
+  <p:cSld>
+    <p:spTree>
+      <p:nvGrpSpPr>
+        <p:cNvPr id="1" name="">
+          <a:extLst>
+            <a:ext uri="{FF2B5EF4-FFF2-40B4-BE49-F238E27FC236}">
+              <a16:creationId xmlns:a16="http://schemas.microsoft.com/office/drawing/2014/main" id="{5124A14F-97E0-08F0-1B77-53C3145F150E}"/>
+            </a:ext>
+          </a:extLst>
+        </p:cNvPr>
+        <p:cNvGrpSpPr/>
+        <p:nvPr/>
+      </p:nvGrpSpPr>
+      <p:grpSpPr>
+        <a:xfrm>
+          <a:off x="0" y="0"/>
+          <a:ext cx="0" cy="0"/>
+          <a:chOff x="0" y="0"/>
+          <a:chExt cx="0" cy="0"/>
+        </a:xfrm>
+      </p:grpSpPr>
+      <p:sp>
+        <p:nvSpPr>
+          <p:cNvPr id="43" name="Rechteck 42">
+            <a:extLst>
+              <a:ext uri="{FF2B5EF4-FFF2-40B4-BE49-F238E27FC236}">
+                <a16:creationId xmlns:a16="http://schemas.microsoft.com/office/drawing/2014/main" id="{BDA02AB1-3F59-293B-85D1-01AD8553B367}"/>
+              </a:ext>
+            </a:extLst>
+          </p:cNvPr>
+          <p:cNvSpPr/>
+          <p:nvPr/>
+        </p:nvSpPr>
+        <p:spPr>
+          <a:xfrm>
+            <a:off x="9448803" y="3345180"/>
+            <a:ext cx="2080258" cy="3147694"/>
+          </a:xfrm>
+          <a:prstGeom prst="rect">
+            <a:avLst/>
+          </a:prstGeom>
+        </p:spPr>
+        <p:style>
+          <a:lnRef idx="2">
+            <a:schemeClr val="accent4">
+              <a:shade val="15000"/>
+            </a:schemeClr>
+          </a:lnRef>
+          <a:fillRef idx="1">
+            <a:schemeClr val="accent4"/>
+          </a:fillRef>
+          <a:effectRef idx="0">
+            <a:schemeClr val="accent4"/>
+          </a:effectRef>
+          <a:fontRef idx="minor">
+            <a:schemeClr val="lt1"/>
+          </a:fontRef>
+        </p:style>
+        <p:txBody>
+          <a:bodyPr rtlCol="0" anchor="t"/>
+          <a:lstStyle/>
+          <a:p>
+            <a:r>
+              <a:rPr lang="de-DE" dirty="0"/>
+              <a:t>Hauptfenster</a:t>
+            </a:r>
+          </a:p>
+        </p:txBody>
+      </p:sp>
+      <p:sp>
+        <p:nvSpPr>
+          <p:cNvPr id="14" name="Rechteck 13">
+            <a:extLst>
+              <a:ext uri="{FF2B5EF4-FFF2-40B4-BE49-F238E27FC236}">
+                <a16:creationId xmlns:a16="http://schemas.microsoft.com/office/drawing/2014/main" id="{919C10EA-F66D-425E-36C5-7D5308790281}"/>
+              </a:ext>
+            </a:extLst>
+          </p:cNvPr>
+          <p:cNvSpPr/>
+          <p:nvPr/>
+        </p:nvSpPr>
+        <p:spPr>
+          <a:xfrm>
+            <a:off x="4838700" y="1531621"/>
+            <a:ext cx="4419600" cy="1293020"/>
+          </a:xfrm>
+          <a:prstGeom prst="rect">
+            <a:avLst/>
+          </a:prstGeom>
+        </p:spPr>
+        <p:style>
+          <a:lnRef idx="2">
+            <a:schemeClr val="accent4">
+              <a:shade val="15000"/>
+            </a:schemeClr>
+          </a:lnRef>
+          <a:fillRef idx="1">
+            <a:schemeClr val="accent4"/>
+          </a:fillRef>
+          <a:effectRef idx="0">
+            <a:schemeClr val="accent4"/>
+          </a:effectRef>
+          <a:fontRef idx="minor">
+            <a:schemeClr val="lt1"/>
+          </a:fontRef>
+        </p:style>
+        <p:txBody>
+          <a:bodyPr rtlCol="0" anchor="t"/>
+          <a:lstStyle/>
+          <a:p>
+            <a:r>
+              <a:rPr lang="de-DE" dirty="0"/>
+              <a:t>Anmelde Maske</a:t>
+            </a:r>
+          </a:p>
+        </p:txBody>
+      </p:sp>
+      <p:sp>
+        <p:nvSpPr>
+          <p:cNvPr id="13" name="Rechteck 12">
+            <a:extLst>
+              <a:ext uri="{FF2B5EF4-FFF2-40B4-BE49-F238E27FC236}">
+                <a16:creationId xmlns:a16="http://schemas.microsoft.com/office/drawing/2014/main" id="{18C6B5CE-4283-5D9A-23D8-F16431C0AB85}"/>
+              </a:ext>
+            </a:extLst>
+          </p:cNvPr>
+          <p:cNvSpPr/>
+          <p:nvPr/>
+        </p:nvSpPr>
+        <p:spPr>
+          <a:xfrm>
+            <a:off x="844550" y="1992791"/>
+            <a:ext cx="2622550" cy="4706459"/>
+          </a:xfrm>
+          <a:prstGeom prst="rect">
+            <a:avLst/>
+          </a:prstGeom>
+        </p:spPr>
+        <p:style>
+          <a:lnRef idx="2">
+            <a:schemeClr val="accent4">
+              <a:shade val="15000"/>
+            </a:schemeClr>
+          </a:lnRef>
+          <a:fillRef idx="1">
+            <a:schemeClr val="accent4"/>
+          </a:fillRef>
+          <a:effectRef idx="0">
+            <a:schemeClr val="accent4"/>
+          </a:effectRef>
+          <a:fontRef idx="minor">
+            <a:schemeClr val="lt1"/>
+          </a:fontRef>
+        </p:style>
+        <p:txBody>
+          <a:bodyPr rtlCol="0" anchor="t"/>
+          <a:lstStyle/>
+          <a:p>
+            <a:r>
+              <a:rPr lang="de-DE" dirty="0"/>
+              <a:t>Datei</a:t>
+            </a:r>
+          </a:p>
+        </p:txBody>
+      </p:sp>
+      <p:sp>
+        <p:nvSpPr>
+          <p:cNvPr id="2" name="Titel 1">
+            <a:extLst>
+              <a:ext uri="{FF2B5EF4-FFF2-40B4-BE49-F238E27FC236}">
+                <a16:creationId xmlns:a16="http://schemas.microsoft.com/office/drawing/2014/main" id="{C214F00C-BEB9-D006-DCA7-BAEE271924B2}"/>
               </a:ext>
             </a:extLst>
           </p:cNvPr>
@@ -7440,32 +9562,941 @@
             <a:spLocks noGrp="1"/>
           </p:cNvSpPr>
           <p:nvPr>
-            <p:ph idx="1"/>
+            <p:ph type="title"/>
           </p:nvPr>
         </p:nvSpPr>
         <p:spPr/>
         <p:txBody>
-          <a:bodyPr>
-            <a:normAutofit/>
+          <a:bodyPr/>
+          <a:lstStyle/>
+          <a:p>
+            <a:r>
+              <a:rPr lang="de-DE" b="1" dirty="0">
+                <a:effectLst>
+                  <a:outerShdw blurRad="38100" dist="38100" dir="2700000" algn="tl">
+                    <a:srgbClr val="000000">
+                      <a:alpha val="43137"/>
+                    </a:srgbClr>
+                  </a:outerShdw>
+                </a:effectLst>
+              </a:rPr>
+              <a:t>Umsetzung</a:t>
+            </a:r>
+            <a:r>
+              <a:rPr lang="de-DE" dirty="0">
+                <a:effectLst>
+                  <a:outerShdw blurRad="38100" dist="38100" dir="2700000" algn="tl">
+                    <a:srgbClr val="000000">
+                      <a:alpha val="43137"/>
+                    </a:srgbClr>
+                  </a:outerShdw>
+                </a:effectLst>
+              </a:rPr>
+              <a:t> - Entschlüsselung</a:t>
+            </a:r>
+          </a:p>
+        </p:txBody>
+      </p:sp>
+      <p:sp>
+        <p:nvSpPr>
+          <p:cNvPr id="4" name="Rechteck 3">
+            <a:extLst>
+              <a:ext uri="{FF2B5EF4-FFF2-40B4-BE49-F238E27FC236}">
+                <a16:creationId xmlns:a16="http://schemas.microsoft.com/office/drawing/2014/main" id="{2849438B-27BD-3705-A1BB-2677A865DA37}"/>
+              </a:ext>
+            </a:extLst>
+          </p:cNvPr>
+          <p:cNvSpPr/>
+          <p:nvPr/>
+        </p:nvSpPr>
+        <p:spPr>
+          <a:xfrm>
+            <a:off x="4373562" y="4052888"/>
+            <a:ext cx="4624388" cy="1166811"/>
+          </a:xfrm>
+          <a:custGeom>
+            <a:avLst/>
+            <a:gdLst>
+              <a:gd name="connsiteX0" fmla="*/ 0 w 4622800"/>
+              <a:gd name="connsiteY0" fmla="*/ 0 h 1166811"/>
+              <a:gd name="connsiteX1" fmla="*/ 4622800 w 4622800"/>
+              <a:gd name="connsiteY1" fmla="*/ 0 h 1166811"/>
+              <a:gd name="connsiteX2" fmla="*/ 4622800 w 4622800"/>
+              <a:gd name="connsiteY2" fmla="*/ 1166811 h 1166811"/>
+              <a:gd name="connsiteX3" fmla="*/ 0 w 4622800"/>
+              <a:gd name="connsiteY3" fmla="*/ 1166811 h 1166811"/>
+              <a:gd name="connsiteX4" fmla="*/ 0 w 4622800"/>
+              <a:gd name="connsiteY4" fmla="*/ 0 h 1166811"/>
+              <a:gd name="connsiteX0" fmla="*/ 6350 w 4629150"/>
+              <a:gd name="connsiteY0" fmla="*/ 0 h 1166811"/>
+              <a:gd name="connsiteX1" fmla="*/ 4629150 w 4629150"/>
+              <a:gd name="connsiteY1" fmla="*/ 0 h 1166811"/>
+              <a:gd name="connsiteX2" fmla="*/ 4629150 w 4629150"/>
+              <a:gd name="connsiteY2" fmla="*/ 1166811 h 1166811"/>
+              <a:gd name="connsiteX3" fmla="*/ 6350 w 4629150"/>
+              <a:gd name="connsiteY3" fmla="*/ 1166811 h 1166811"/>
+              <a:gd name="connsiteX4" fmla="*/ 0 w 4629150"/>
+              <a:gd name="connsiteY4" fmla="*/ 931862 h 1166811"/>
+              <a:gd name="connsiteX5" fmla="*/ 6350 w 4629150"/>
+              <a:gd name="connsiteY5" fmla="*/ 0 h 1166811"/>
+              <a:gd name="connsiteX0" fmla="*/ 6350 w 4629150"/>
+              <a:gd name="connsiteY0" fmla="*/ 0 h 1166811"/>
+              <a:gd name="connsiteX1" fmla="*/ 4629150 w 4629150"/>
+              <a:gd name="connsiteY1" fmla="*/ 0 h 1166811"/>
+              <a:gd name="connsiteX2" fmla="*/ 4629150 w 4629150"/>
+              <a:gd name="connsiteY2" fmla="*/ 1166811 h 1166811"/>
+              <a:gd name="connsiteX3" fmla="*/ 6350 w 4629150"/>
+              <a:gd name="connsiteY3" fmla="*/ 1166811 h 1166811"/>
+              <a:gd name="connsiteX4" fmla="*/ 0 w 4629150"/>
+              <a:gd name="connsiteY4" fmla="*/ 341312 h 1166811"/>
+              <a:gd name="connsiteX5" fmla="*/ 6350 w 4629150"/>
+              <a:gd name="connsiteY5" fmla="*/ 0 h 1166811"/>
+              <a:gd name="connsiteX0" fmla="*/ 1588 w 4624388"/>
+              <a:gd name="connsiteY0" fmla="*/ 0 h 1166811"/>
+              <a:gd name="connsiteX1" fmla="*/ 4624388 w 4624388"/>
+              <a:gd name="connsiteY1" fmla="*/ 0 h 1166811"/>
+              <a:gd name="connsiteX2" fmla="*/ 4624388 w 4624388"/>
+              <a:gd name="connsiteY2" fmla="*/ 1166811 h 1166811"/>
+              <a:gd name="connsiteX3" fmla="*/ 1588 w 4624388"/>
+              <a:gd name="connsiteY3" fmla="*/ 1166811 h 1166811"/>
+              <a:gd name="connsiteX4" fmla="*/ 0 w 4624388"/>
+              <a:gd name="connsiteY4" fmla="*/ 341312 h 1166811"/>
+              <a:gd name="connsiteX5" fmla="*/ 1588 w 4624388"/>
+              <a:gd name="connsiteY5" fmla="*/ 0 h 1166811"/>
+            </a:gdLst>
+            <a:ahLst/>
+            <a:cxnLst>
+              <a:cxn ang="0">
+                <a:pos x="connsiteX0" y="connsiteY0"/>
+              </a:cxn>
+              <a:cxn ang="0">
+                <a:pos x="connsiteX1" y="connsiteY1"/>
+              </a:cxn>
+              <a:cxn ang="0">
+                <a:pos x="connsiteX2" y="connsiteY2"/>
+              </a:cxn>
+              <a:cxn ang="0">
+                <a:pos x="connsiteX3" y="connsiteY3"/>
+              </a:cxn>
+              <a:cxn ang="0">
+                <a:pos x="connsiteX4" y="connsiteY4"/>
+              </a:cxn>
+              <a:cxn ang="0">
+                <a:pos x="connsiteX5" y="connsiteY5"/>
+              </a:cxn>
+            </a:cxnLst>
+            <a:rect l="l" t="t" r="r" b="b"/>
+            <a:pathLst>
+              <a:path w="4624388" h="1166811">
+                <a:moveTo>
+                  <a:pt x="1588" y="0"/>
+                </a:moveTo>
+                <a:lnTo>
+                  <a:pt x="4624388" y="0"/>
+                </a:lnTo>
+                <a:lnTo>
+                  <a:pt x="4624388" y="1166811"/>
+                </a:lnTo>
+                <a:lnTo>
+                  <a:pt x="1588" y="1166811"/>
+                </a:lnTo>
+                <a:cubicBezTo>
+                  <a:pt x="-529" y="891645"/>
+                  <a:pt x="2117" y="616478"/>
+                  <a:pt x="0" y="341312"/>
+                </a:cubicBezTo>
+                <a:cubicBezTo>
+                  <a:pt x="2117" y="30691"/>
+                  <a:pt x="-529" y="310621"/>
+                  <a:pt x="1588" y="0"/>
+                </a:cubicBezTo>
+                <a:close/>
+              </a:path>
+            </a:pathLst>
+          </a:custGeom>
+        </p:spPr>
+        <p:style>
+          <a:lnRef idx="2">
+            <a:schemeClr val="accent1">
+              <a:shade val="15000"/>
+            </a:schemeClr>
+          </a:lnRef>
+          <a:fillRef idx="1">
+            <a:schemeClr val="accent1"/>
+          </a:fillRef>
+          <a:effectRef idx="0">
+            <a:schemeClr val="accent1"/>
+          </a:effectRef>
+          <a:fontRef idx="minor">
+            <a:schemeClr val="lt1"/>
+          </a:fontRef>
+        </p:style>
+        <p:txBody>
+          <a:bodyPr rtlCol="0" anchor="ctr"/>
+          <a:lstStyle/>
+          <a:p>
+            <a:pPr algn="ctr"/>
+            <a:r>
+              <a:rPr lang="de-DE" dirty="0"/>
+              <a:t>Entschlüsselung mittels</a:t>
+            </a:r>
+          </a:p>
+          <a:p>
+            <a:pPr algn="ctr"/>
+            <a:r>
+              <a:rPr lang="de-DE" dirty="0"/>
+              <a:t>AES256-GCM</a:t>
+            </a:r>
+          </a:p>
+        </p:txBody>
+      </p:sp>
+      <p:sp>
+        <p:nvSpPr>
+          <p:cNvPr id="5" name="Rechteck 4">
+            <a:extLst>
+              <a:ext uri="{FF2B5EF4-FFF2-40B4-BE49-F238E27FC236}">
+                <a16:creationId xmlns:a16="http://schemas.microsoft.com/office/drawing/2014/main" id="{06F2827B-8297-F0EA-FD45-9B886500F5DF}"/>
+              </a:ext>
+            </a:extLst>
+          </p:cNvPr>
+          <p:cNvSpPr/>
+          <p:nvPr/>
+        </p:nvSpPr>
+        <p:spPr>
+          <a:xfrm>
+            <a:off x="1200150" y="2501900"/>
+            <a:ext cx="1803400" cy="438150"/>
+          </a:xfrm>
+          <a:prstGeom prst="rect">
+            <a:avLst/>
+          </a:prstGeom>
+        </p:spPr>
+        <p:style>
+          <a:lnRef idx="2">
+            <a:schemeClr val="accent1">
+              <a:shade val="15000"/>
+            </a:schemeClr>
+          </a:lnRef>
+          <a:fillRef idx="1">
+            <a:schemeClr val="accent1"/>
+          </a:fillRef>
+          <a:effectRef idx="0">
+            <a:schemeClr val="accent1"/>
+          </a:effectRef>
+          <a:fontRef idx="minor">
+            <a:schemeClr val="lt1"/>
+          </a:fontRef>
+        </p:style>
+        <p:txBody>
+          <a:bodyPr rtlCol="0" anchor="ctr"/>
+          <a:lstStyle/>
+          <a:p>
+            <a:pPr algn="ctr"/>
+            <a:r>
+              <a:rPr lang="de-DE" dirty="0"/>
+              <a:t>Salt</a:t>
+            </a:r>
+          </a:p>
+        </p:txBody>
+      </p:sp>
+      <p:sp>
+        <p:nvSpPr>
+          <p:cNvPr id="6" name="Rechteck 5">
+            <a:extLst>
+              <a:ext uri="{FF2B5EF4-FFF2-40B4-BE49-F238E27FC236}">
+                <a16:creationId xmlns:a16="http://schemas.microsoft.com/office/drawing/2014/main" id="{994389CE-32AA-1628-DD75-6BBFF8EED003}"/>
+              </a:ext>
+            </a:extLst>
+          </p:cNvPr>
+          <p:cNvSpPr/>
+          <p:nvPr/>
+        </p:nvSpPr>
+        <p:spPr>
+          <a:xfrm>
+            <a:off x="1200150" y="3061494"/>
+            <a:ext cx="1803400" cy="438150"/>
+          </a:xfrm>
+          <a:prstGeom prst="rect">
+            <a:avLst/>
+          </a:prstGeom>
+        </p:spPr>
+        <p:style>
+          <a:lnRef idx="2">
+            <a:schemeClr val="accent1">
+              <a:shade val="15000"/>
+            </a:schemeClr>
+          </a:lnRef>
+          <a:fillRef idx="1">
+            <a:schemeClr val="accent1"/>
+          </a:fillRef>
+          <a:effectRef idx="0">
+            <a:schemeClr val="accent1"/>
+          </a:effectRef>
+          <a:fontRef idx="minor">
+            <a:schemeClr val="lt1"/>
+          </a:fontRef>
+        </p:style>
+        <p:txBody>
+          <a:bodyPr rtlCol="0" anchor="ctr"/>
+          <a:lstStyle/>
+          <a:p>
+            <a:pPr algn="ctr"/>
+            <a:r>
+              <a:rPr lang="de-DE" dirty="0"/>
+              <a:t>IV</a:t>
+            </a:r>
+          </a:p>
+        </p:txBody>
+      </p:sp>
+      <p:sp>
+        <p:nvSpPr>
+          <p:cNvPr id="7" name="Rechteck 6">
+            <a:extLst>
+              <a:ext uri="{FF2B5EF4-FFF2-40B4-BE49-F238E27FC236}">
+                <a16:creationId xmlns:a16="http://schemas.microsoft.com/office/drawing/2014/main" id="{ED833B69-5A20-83B1-0C6C-825B7D7D965B}"/>
+              </a:ext>
+            </a:extLst>
+          </p:cNvPr>
+          <p:cNvSpPr/>
+          <p:nvPr/>
+        </p:nvSpPr>
+        <p:spPr>
+          <a:xfrm>
+            <a:off x="1200150" y="3618706"/>
+            <a:ext cx="1803400" cy="2909093"/>
+          </a:xfrm>
+          <a:prstGeom prst="rect">
+            <a:avLst/>
+          </a:prstGeom>
+        </p:spPr>
+        <p:style>
+          <a:lnRef idx="2">
+            <a:schemeClr val="accent1">
+              <a:shade val="15000"/>
+            </a:schemeClr>
+          </a:lnRef>
+          <a:fillRef idx="1">
+            <a:schemeClr val="accent1"/>
+          </a:fillRef>
+          <a:effectRef idx="0">
+            <a:schemeClr val="accent1"/>
+          </a:effectRef>
+          <a:fontRef idx="minor">
+            <a:schemeClr val="lt1"/>
+          </a:fontRef>
+        </p:style>
+        <p:txBody>
+          <a:bodyPr rtlCol="0" anchor="ctr"/>
+          <a:lstStyle/>
+          <a:p>
+            <a:pPr algn="ctr"/>
+            <a:r>
+              <a:rPr lang="de-DE" dirty="0"/>
+              <a:t>Verschlüsselte</a:t>
+            </a:r>
+          </a:p>
+          <a:p>
+            <a:pPr algn="ctr"/>
+            <a:r>
+              <a:rPr lang="de-DE" dirty="0"/>
+              <a:t>Daten</a:t>
+            </a:r>
+          </a:p>
+        </p:txBody>
+      </p:sp>
+      <p:sp>
+        <p:nvSpPr>
+          <p:cNvPr id="8" name="Rechteck 7">
+            <a:extLst>
+              <a:ext uri="{FF2B5EF4-FFF2-40B4-BE49-F238E27FC236}">
+                <a16:creationId xmlns:a16="http://schemas.microsoft.com/office/drawing/2014/main" id="{1730D50A-D22C-1AA8-6759-71B9D20CED97}"/>
+              </a:ext>
+            </a:extLst>
+          </p:cNvPr>
+          <p:cNvSpPr/>
+          <p:nvPr/>
+        </p:nvSpPr>
+        <p:spPr>
+          <a:xfrm>
+            <a:off x="7239000" y="2003901"/>
+            <a:ext cx="1758950" cy="671512"/>
+          </a:xfrm>
+          <a:prstGeom prst="rect">
+            <a:avLst/>
+          </a:prstGeom>
+        </p:spPr>
+        <p:style>
+          <a:lnRef idx="2">
+            <a:schemeClr val="accent1">
+              <a:shade val="15000"/>
+            </a:schemeClr>
+          </a:lnRef>
+          <a:fillRef idx="1">
+            <a:schemeClr val="accent1"/>
+          </a:fillRef>
+          <a:effectRef idx="0">
+            <a:schemeClr val="accent1"/>
+          </a:effectRef>
+          <a:fontRef idx="minor">
+            <a:schemeClr val="lt1"/>
+          </a:fontRef>
+        </p:style>
+        <p:txBody>
+          <a:bodyPr rtlCol="0" anchor="ctr"/>
+          <a:lstStyle/>
+          <a:p>
+            <a:pPr algn="ctr"/>
+            <a:r>
+              <a:rPr lang="de-DE" dirty="0"/>
+              <a:t>Master</a:t>
+            </a:r>
+          </a:p>
+          <a:p>
+            <a:pPr algn="ctr"/>
+            <a:r>
+              <a:rPr lang="de-DE" dirty="0"/>
+              <a:t>Passwort</a:t>
+            </a:r>
+          </a:p>
+        </p:txBody>
+      </p:sp>
+      <p:sp>
+        <p:nvSpPr>
+          <p:cNvPr id="9" name="Rechteck 8">
+            <a:extLst>
+              <a:ext uri="{FF2B5EF4-FFF2-40B4-BE49-F238E27FC236}">
+                <a16:creationId xmlns:a16="http://schemas.microsoft.com/office/drawing/2014/main" id="{FFE069DD-118B-E4B3-33C9-A6604BC498FD}"/>
+              </a:ext>
+            </a:extLst>
+          </p:cNvPr>
+          <p:cNvSpPr/>
+          <p:nvPr/>
+        </p:nvSpPr>
+        <p:spPr>
+          <a:xfrm>
+            <a:off x="5791200" y="3066257"/>
+            <a:ext cx="3206750" cy="673100"/>
+          </a:xfrm>
+          <a:prstGeom prst="rect">
+            <a:avLst/>
+          </a:prstGeom>
+        </p:spPr>
+        <p:style>
+          <a:lnRef idx="2">
+            <a:schemeClr val="accent1">
+              <a:shade val="15000"/>
+            </a:schemeClr>
+          </a:lnRef>
+          <a:fillRef idx="1">
+            <a:schemeClr val="accent1"/>
+          </a:fillRef>
+          <a:effectRef idx="0">
+            <a:schemeClr val="accent1"/>
+          </a:effectRef>
+          <a:fontRef idx="minor">
+            <a:schemeClr val="lt1"/>
+          </a:fontRef>
+        </p:style>
+        <p:txBody>
+          <a:bodyPr rtlCol="0" anchor="ctr"/>
+          <a:lstStyle/>
+          <a:p>
+            <a:pPr algn="ctr"/>
+            <a:r>
+              <a:rPr lang="de-DE" dirty="0"/>
+              <a:t>Key Ableitung mittels</a:t>
+            </a:r>
+          </a:p>
+          <a:p>
+            <a:pPr algn="ctr"/>
+            <a:r>
+              <a:rPr lang="de-DE" dirty="0"/>
+              <a:t>PBKDF2-HMAC-SHA256</a:t>
+            </a:r>
+          </a:p>
+        </p:txBody>
+      </p:sp>
+      <p:sp>
+        <p:nvSpPr>
+          <p:cNvPr id="12" name="Rechteck 11">
+            <a:extLst>
+              <a:ext uri="{FF2B5EF4-FFF2-40B4-BE49-F238E27FC236}">
+                <a16:creationId xmlns:a16="http://schemas.microsoft.com/office/drawing/2014/main" id="{4DD0C6F4-E1A8-691E-1482-CE5626E2AA1A}"/>
+              </a:ext>
+            </a:extLst>
+          </p:cNvPr>
+          <p:cNvSpPr/>
+          <p:nvPr/>
+        </p:nvSpPr>
+        <p:spPr>
+          <a:xfrm>
+            <a:off x="9969500" y="4052888"/>
+            <a:ext cx="1111250" cy="2124075"/>
+          </a:xfrm>
+          <a:prstGeom prst="rect">
+            <a:avLst/>
+          </a:prstGeom>
+        </p:spPr>
+        <p:style>
+          <a:lnRef idx="2">
+            <a:schemeClr val="accent1">
+              <a:shade val="15000"/>
+            </a:schemeClr>
+          </a:lnRef>
+          <a:fillRef idx="1">
+            <a:schemeClr val="accent1"/>
+          </a:fillRef>
+          <a:effectRef idx="0">
+            <a:schemeClr val="accent1"/>
+          </a:effectRef>
+          <a:fontRef idx="minor">
+            <a:schemeClr val="lt1"/>
+          </a:fontRef>
+        </p:style>
+        <p:txBody>
+          <a:bodyPr rtlCol="0" anchor="ctr"/>
+          <a:lstStyle/>
+          <a:p>
+            <a:pPr algn="ctr"/>
+            <a:r>
+              <a:rPr lang="de-DE" dirty="0"/>
+              <a:t>Klartext</a:t>
+            </a:r>
+          </a:p>
+          <a:p>
+            <a:pPr algn="ctr"/>
+            <a:r>
+              <a:rPr lang="de-DE" dirty="0"/>
+              <a:t>Daten</a:t>
+            </a:r>
+          </a:p>
+        </p:txBody>
+      </p:sp>
+      <p:cxnSp>
+        <p:nvCxnSpPr>
+          <p:cNvPr id="16" name="Verbinder: gewinkelt 15">
+            <a:extLst>
+              <a:ext uri="{FF2B5EF4-FFF2-40B4-BE49-F238E27FC236}">
+                <a16:creationId xmlns:a16="http://schemas.microsoft.com/office/drawing/2014/main" id="{81234E06-A9F2-93EB-1CAE-E5A447A55000}"/>
+              </a:ext>
+            </a:extLst>
+          </p:cNvPr>
+          <p:cNvCxnSpPr>
+            <a:cxnSpLocks/>
+            <a:stCxn id="5" idx="3"/>
+            <a:endCxn id="9" idx="1"/>
+          </p:cNvCxnSpPr>
+          <p:nvPr/>
+        </p:nvCxnSpPr>
+        <p:spPr>
+          <a:xfrm>
+            <a:off x="3003550" y="2720975"/>
+            <a:ext cx="2787650" cy="681832"/>
+          </a:xfrm>
+          <a:prstGeom prst="bentConnector3">
+            <a:avLst>
+              <a:gd name="adj1" fmla="val 50000"/>
+            </a:avLst>
+          </a:prstGeom>
+          <a:ln w="57150">
+            <a:tailEnd type="triangle"/>
+          </a:ln>
+        </p:spPr>
+        <p:style>
+          <a:lnRef idx="2">
+            <a:schemeClr val="accent6"/>
+          </a:lnRef>
+          <a:fillRef idx="0">
+            <a:schemeClr val="accent6"/>
+          </a:fillRef>
+          <a:effectRef idx="1">
+            <a:schemeClr val="accent6"/>
+          </a:effectRef>
+          <a:fontRef idx="minor">
+            <a:schemeClr val="tx1"/>
+          </a:fontRef>
+        </p:style>
+      </p:cxnSp>
+      <p:cxnSp>
+        <p:nvCxnSpPr>
+          <p:cNvPr id="29" name="Verbinder: gewinkelt 28">
+            <a:extLst>
+              <a:ext uri="{FF2B5EF4-FFF2-40B4-BE49-F238E27FC236}">
+                <a16:creationId xmlns:a16="http://schemas.microsoft.com/office/drawing/2014/main" id="{D44191E1-B084-398A-7949-679C634281C4}"/>
+              </a:ext>
+            </a:extLst>
+          </p:cNvPr>
+          <p:cNvCxnSpPr>
+            <a:stCxn id="6" idx="3"/>
+          </p:cNvCxnSpPr>
+          <p:nvPr/>
+        </p:nvCxnSpPr>
+        <p:spPr>
+          <a:xfrm>
+            <a:off x="3003550" y="3280569"/>
+            <a:ext cx="1368425" cy="1355724"/>
+          </a:xfrm>
+          <a:prstGeom prst="bentConnector3">
+            <a:avLst/>
+          </a:prstGeom>
+          <a:ln w="57150">
+            <a:tailEnd type="triangle"/>
+          </a:ln>
+        </p:spPr>
+        <p:style>
+          <a:lnRef idx="2">
+            <a:schemeClr val="accent6"/>
+          </a:lnRef>
+          <a:fillRef idx="0">
+            <a:schemeClr val="accent6"/>
+          </a:fillRef>
+          <a:effectRef idx="1">
+            <a:schemeClr val="accent6"/>
+          </a:effectRef>
+          <a:fontRef idx="minor">
+            <a:schemeClr val="tx1"/>
+          </a:fontRef>
+        </p:style>
+      </p:cxnSp>
+      <p:cxnSp>
+        <p:nvCxnSpPr>
+          <p:cNvPr id="31" name="Verbinder: gewinkelt 30">
+            <a:extLst>
+              <a:ext uri="{FF2B5EF4-FFF2-40B4-BE49-F238E27FC236}">
+                <a16:creationId xmlns:a16="http://schemas.microsoft.com/office/drawing/2014/main" id="{0B22B8A4-404D-3D63-6BD2-B1B32A387D97}"/>
+              </a:ext>
+            </a:extLst>
+          </p:cNvPr>
+          <p:cNvCxnSpPr>
+            <a:cxnSpLocks/>
+            <a:stCxn id="7" idx="3"/>
+          </p:cNvCxnSpPr>
+          <p:nvPr/>
+        </p:nvCxnSpPr>
+        <p:spPr>
+          <a:xfrm flipV="1">
+            <a:off x="3003550" y="4855368"/>
+            <a:ext cx="1365250" cy="217885"/>
+          </a:xfrm>
+          <a:prstGeom prst="bentConnector3">
+            <a:avLst/>
+          </a:prstGeom>
+          <a:ln w="57150">
+            <a:tailEnd type="triangle"/>
+          </a:ln>
+        </p:spPr>
+        <p:style>
+          <a:lnRef idx="2">
+            <a:schemeClr val="accent6"/>
+          </a:lnRef>
+          <a:fillRef idx="0">
+            <a:schemeClr val="accent6"/>
+          </a:fillRef>
+          <a:effectRef idx="1">
+            <a:schemeClr val="accent6"/>
+          </a:effectRef>
+          <a:fontRef idx="minor">
+            <a:schemeClr val="tx1"/>
+          </a:fontRef>
+        </p:style>
+      </p:cxnSp>
+      <p:cxnSp>
+        <p:nvCxnSpPr>
+          <p:cNvPr id="38" name="Gerade Verbindung mit Pfeil 37">
+            <a:extLst>
+              <a:ext uri="{FF2B5EF4-FFF2-40B4-BE49-F238E27FC236}">
+                <a16:creationId xmlns:a16="http://schemas.microsoft.com/office/drawing/2014/main" id="{62ADD9B0-7CD7-0A15-9DA8-5A4BC61251D6}"/>
+              </a:ext>
+            </a:extLst>
+          </p:cNvPr>
+          <p:cNvCxnSpPr>
+            <a:cxnSpLocks/>
+            <a:stCxn id="8" idx="2"/>
+          </p:cNvCxnSpPr>
+          <p:nvPr/>
+        </p:nvCxnSpPr>
+        <p:spPr>
+          <a:xfrm>
+            <a:off x="8118475" y="2675413"/>
+            <a:ext cx="0" cy="386081"/>
+          </a:xfrm>
+          <a:prstGeom prst="straightConnector1">
+            <a:avLst/>
+          </a:prstGeom>
+          <a:ln w="57150">
+            <a:tailEnd type="triangle"/>
+          </a:ln>
+        </p:spPr>
+        <p:style>
+          <a:lnRef idx="2">
+            <a:schemeClr val="accent6"/>
+          </a:lnRef>
+          <a:fillRef idx="0">
+            <a:schemeClr val="accent6"/>
+          </a:fillRef>
+          <a:effectRef idx="1">
+            <a:schemeClr val="accent6"/>
+          </a:effectRef>
+          <a:fontRef idx="minor">
+            <a:schemeClr val="tx1"/>
+          </a:fontRef>
+        </p:style>
+      </p:cxnSp>
+      <p:cxnSp>
+        <p:nvCxnSpPr>
+          <p:cNvPr id="40" name="Gerade Verbindung mit Pfeil 39">
+            <a:extLst>
+              <a:ext uri="{FF2B5EF4-FFF2-40B4-BE49-F238E27FC236}">
+                <a16:creationId xmlns:a16="http://schemas.microsoft.com/office/drawing/2014/main" id="{D415F915-8103-B9D5-4BFF-3C661F683CE2}"/>
+              </a:ext>
+            </a:extLst>
+          </p:cNvPr>
+          <p:cNvCxnSpPr>
+            <a:stCxn id="9" idx="2"/>
+          </p:cNvCxnSpPr>
+          <p:nvPr/>
+        </p:nvCxnSpPr>
+        <p:spPr>
+          <a:xfrm>
+            <a:off x="7394575" y="3739357"/>
+            <a:ext cx="0" cy="313531"/>
+          </a:xfrm>
+          <a:prstGeom prst="straightConnector1">
+            <a:avLst/>
+          </a:prstGeom>
+          <a:ln w="57150">
+            <a:tailEnd type="triangle"/>
+          </a:ln>
+        </p:spPr>
+        <p:style>
+          <a:lnRef idx="2">
+            <a:schemeClr val="accent6"/>
+          </a:lnRef>
+          <a:fillRef idx="0">
+            <a:schemeClr val="accent6"/>
+          </a:fillRef>
+          <a:effectRef idx="1">
+            <a:schemeClr val="accent6"/>
+          </a:effectRef>
+          <a:fontRef idx="minor">
+            <a:schemeClr val="tx1"/>
+          </a:fontRef>
+        </p:style>
+      </p:cxnSp>
+      <p:cxnSp>
+        <p:nvCxnSpPr>
+          <p:cNvPr id="42" name="Gerade Verbindung mit Pfeil 41">
+            <a:extLst>
+              <a:ext uri="{FF2B5EF4-FFF2-40B4-BE49-F238E27FC236}">
+                <a16:creationId xmlns:a16="http://schemas.microsoft.com/office/drawing/2014/main" id="{4442EB5E-B1C9-F03B-3C9A-C5248AB1BCAE}"/>
+              </a:ext>
+            </a:extLst>
+          </p:cNvPr>
+          <p:cNvCxnSpPr/>
+          <p:nvPr/>
+        </p:nvCxnSpPr>
+        <p:spPr>
+          <a:xfrm>
+            <a:off x="8997950" y="4636293"/>
+            <a:ext cx="971550" cy="0"/>
+          </a:xfrm>
+          <a:prstGeom prst="straightConnector1">
+            <a:avLst/>
+          </a:prstGeom>
+          <a:ln w="57150">
+            <a:tailEnd type="triangle"/>
+          </a:ln>
+        </p:spPr>
+        <p:style>
+          <a:lnRef idx="2">
+            <a:schemeClr val="accent6"/>
+          </a:lnRef>
+          <a:fillRef idx="0">
+            <a:schemeClr val="accent6"/>
+          </a:fillRef>
+          <a:effectRef idx="1">
+            <a:schemeClr val="accent6"/>
+          </a:effectRef>
+          <a:fontRef idx="minor">
+            <a:schemeClr val="tx1"/>
+          </a:fontRef>
+        </p:style>
+      </p:cxnSp>
+      <p:sp>
+        <p:nvSpPr>
+          <p:cNvPr id="49" name="Rechteck 48">
+            <a:extLst>
+              <a:ext uri="{FF2B5EF4-FFF2-40B4-BE49-F238E27FC236}">
+                <a16:creationId xmlns:a16="http://schemas.microsoft.com/office/drawing/2014/main" id="{1A6FB173-7311-233C-B84E-D45721B41DCE}"/>
+              </a:ext>
+            </a:extLst>
+          </p:cNvPr>
+          <p:cNvSpPr/>
+          <p:nvPr/>
+        </p:nvSpPr>
+        <p:spPr>
+          <a:xfrm>
+            <a:off x="5219700" y="1992791"/>
+            <a:ext cx="1758950" cy="671512"/>
+          </a:xfrm>
+          <a:prstGeom prst="rect">
+            <a:avLst/>
+          </a:prstGeom>
+        </p:spPr>
+        <p:style>
+          <a:lnRef idx="2">
+            <a:schemeClr val="accent1">
+              <a:shade val="15000"/>
+            </a:schemeClr>
+          </a:lnRef>
+          <a:fillRef idx="1">
+            <a:schemeClr val="accent1"/>
+          </a:fillRef>
+          <a:effectRef idx="0">
+            <a:schemeClr val="accent1"/>
+          </a:effectRef>
+          <a:fontRef idx="minor">
+            <a:schemeClr val="lt1"/>
+          </a:fontRef>
+        </p:style>
+        <p:txBody>
+          <a:bodyPr rtlCol="0" anchor="ctr"/>
+          <a:lstStyle/>
+          <a:p>
+            <a:pPr algn="ctr"/>
+            <a:r>
+              <a:rPr lang="de-DE" dirty="0"/>
+              <a:t>Username</a:t>
+            </a:r>
+          </a:p>
+        </p:txBody>
+      </p:sp>
+      <p:cxnSp>
+        <p:nvCxnSpPr>
+          <p:cNvPr id="51" name="Gerade Verbindung mit Pfeil 50">
+            <a:extLst>
+              <a:ext uri="{FF2B5EF4-FFF2-40B4-BE49-F238E27FC236}">
+                <a16:creationId xmlns:a16="http://schemas.microsoft.com/office/drawing/2014/main" id="{ECFDC101-25A0-E13E-C092-B9F02CCFBEB8}"/>
+              </a:ext>
+            </a:extLst>
+          </p:cNvPr>
+          <p:cNvCxnSpPr>
+            <a:stCxn id="49" idx="1"/>
+          </p:cNvCxnSpPr>
+          <p:nvPr/>
+        </p:nvCxnSpPr>
+        <p:spPr>
+          <a:xfrm flipH="1">
+            <a:off x="3467100" y="2328547"/>
+            <a:ext cx="1752600" cy="11110"/>
+          </a:xfrm>
+          <a:prstGeom prst="straightConnector1">
+            <a:avLst/>
+          </a:prstGeom>
+          <a:ln w="57150">
+            <a:tailEnd type="triangle"/>
+          </a:ln>
+        </p:spPr>
+        <p:style>
+          <a:lnRef idx="2">
+            <a:schemeClr val="accent6"/>
+          </a:lnRef>
+          <a:fillRef idx="0">
+            <a:schemeClr val="accent6"/>
+          </a:fillRef>
+          <a:effectRef idx="1">
+            <a:schemeClr val="accent6"/>
+          </a:effectRef>
+          <a:fontRef idx="minor">
+            <a:schemeClr val="tx1"/>
+          </a:fontRef>
+        </p:style>
+      </p:cxnSp>
+      <p:sp>
+        <p:nvSpPr>
+          <p:cNvPr id="52" name="Textfeld 51">
+            <a:extLst>
+              <a:ext uri="{FF2B5EF4-FFF2-40B4-BE49-F238E27FC236}">
+                <a16:creationId xmlns:a16="http://schemas.microsoft.com/office/drawing/2014/main" id="{8ABF5ADD-F6A1-B199-ED18-FBABCDA7B561}"/>
+              </a:ext>
+            </a:extLst>
+          </p:cNvPr>
+          <p:cNvSpPr txBox="1"/>
+          <p:nvPr/>
+        </p:nvSpPr>
+        <p:spPr>
+          <a:xfrm>
+            <a:off x="3602990" y="2010270"/>
+            <a:ext cx="1296445" cy="307777"/>
+          </a:xfrm>
+          <a:prstGeom prst="rect">
+            <a:avLst/>
+          </a:prstGeom>
+          <a:noFill/>
+        </p:spPr>
+        <p:txBody>
+          <a:bodyPr wrap="none" rtlCol="0">
+            <a:spAutoFit/>
           </a:bodyPr>
           <a:lstStyle/>
           <a:p>
             <a:r>
-              <a:rPr lang="de-DE" sz="2000" dirty="0"/>
-              <a:t>Implementierung von Buttons (Bearbeiten, Kopieren, Anzeigen) in eine </a:t>
-            </a:r>
-            <a:r>
-              <a:rPr lang="de-DE" sz="2000" dirty="0" err="1"/>
-              <a:t>JTable</a:t>
-            </a:r>
-            <a:endParaRPr lang="de-DE" sz="2000" dirty="0"/>
+              <a:rPr lang="de-DE" sz="1400" dirty="0"/>
+              <a:t>Auswahl Datei</a:t>
+            </a:r>
+          </a:p>
+        </p:txBody>
+      </p:sp>
+      <p:sp>
+        <p:nvSpPr>
+          <p:cNvPr id="3" name="Pfeil: nach links 2">
+            <a:extLst>
+              <a:ext uri="{FF2B5EF4-FFF2-40B4-BE49-F238E27FC236}">
+                <a16:creationId xmlns:a16="http://schemas.microsoft.com/office/drawing/2014/main" id="{328B096A-B49E-A1E5-D4CE-E9B3F6A30548}"/>
+              </a:ext>
+            </a:extLst>
+          </p:cNvPr>
+          <p:cNvSpPr/>
+          <p:nvPr/>
+        </p:nvSpPr>
+        <p:spPr>
+          <a:xfrm rot="10800000">
+            <a:off x="4541520" y="5768340"/>
+            <a:ext cx="3576955" cy="759459"/>
+          </a:xfrm>
+          <a:prstGeom prst="leftArrow">
+            <a:avLst/>
+          </a:prstGeom>
+        </p:spPr>
+        <p:style>
+          <a:lnRef idx="2">
+            <a:schemeClr val="accent2">
+              <a:shade val="15000"/>
+            </a:schemeClr>
+          </a:lnRef>
+          <a:fillRef idx="1">
+            <a:schemeClr val="accent2"/>
+          </a:fillRef>
+          <a:effectRef idx="0">
+            <a:schemeClr val="accent2"/>
+          </a:effectRef>
+          <a:fontRef idx="minor">
+            <a:schemeClr val="lt1"/>
+          </a:fontRef>
+        </p:style>
+        <p:txBody>
+          <a:bodyPr rtlCol="0" anchor="ctr"/>
+          <a:lstStyle/>
+          <a:p>
+            <a:pPr algn="ctr"/>
+            <a:endParaRPr lang="de-DE"/>
           </a:p>
         </p:txBody>
       </p:sp>
     </p:spTree>
     <p:extLst>
       <p:ext uri="{BB962C8B-B14F-4D97-AF65-F5344CB8AC3E}">
-        <p14:creationId xmlns:p14="http://schemas.microsoft.com/office/powerpoint/2010/main" val="3903202141"/>
+        <p14:creationId xmlns:p14="http://schemas.microsoft.com/office/powerpoint/2010/main" val="290165874"/>
       </p:ext>
     </p:extLst>
   </p:cSld>

</xml_diff>